<commit_message>
GRANDRIMS x Mercedes-Benz deck: add G-Class, wheels and AMG Carbon Ceramic photos (slides 5, 8, 9, 10)
Co-Authored-By: Claude Sonnet 5.5 <noreply@anthropic.com>
Claude-Session: https://claude.ai/code/session_01Gh1izjdNn5w7VE18yf9oT6
</commit_message>
<xml_diff>
--- a/grandrims-mb/GRANDRIMS_Mercedes-Benz_KP.pptx
+++ b/grandrims-mb/GRANDRIMS_Mercedes-Benz_KP.pptx
@@ -584,7 +584,7 @@
           <a:lstStyle/>
           <a:p>
             <a:r>
-              <a:t>ТРЕБУЕТСЯ: (1) фото комплекта G 63 — золотые суппорты AMG + карбон-керамические диски (кадр 1080×640), заменить «PHOTO SLOT — G 63 carbon ceramic»; (2) внести цену вместо «…» в текстовом поле «Price text». Цена не придумана.</a:t>
+              <a:t>ТРЕБУЕТСЯ: внести цену вместо «…» в текстовом поле «Price text». Цена не придумана.</a:t>
             </a:r>
           </a:p>
         </p:txBody>
@@ -1074,7 +1074,7 @@
           <a:lstStyle/>
           <a:p>
             <a:r>
-              <a:t>Дизайн дисков. Кадры — фрагменты фото автомобилей (S-Class, GLS, Maybach GLS, W124). При получении предметных фото дисков заменить плитки 01–04.</a:t>
+              <a:t>Дизайн дисков. 01 — предметное фото комплекта GRANDRIMS; 02–04 — фрагменты фото автомобилей (S-Class, Maybach GLS, GLS).</a:t>
             </a:r>
           </a:p>
         </p:txBody>
@@ -1284,7 +1284,7 @@
           <a:lstStyle/>
           <a:p>
             <a:r>
-              <a:t>ТРЕБУЕТСЯ ФОТО: G-Class с установленными дисками. Правой кнопкой по фону → «Изменить рисунок» (кадр 9:16, 1080×1920). Затемняющий градиент и текст останутся.</a:t>
+              <a:t>G-Class. Водяной знак с исходного фото убран кадрированием.</a:t>
             </a:r>
           </a:p>
         </p:txBody>
@@ -1354,7 +1354,7 @@
           <a:lstStyle/>
           <a:p>
             <a:r>
-              <a:t>ТРЕБУЕТСЯ ФОТО: золотые суппорты AMG и карбон-керамические диски (кадр 1080×860). Заменить рисунок «PHOTO SLOT — brakes».</a:t>
+              <a:t>Тормозные комплекты AMG Carbon Ceramic. Водяной знак с исходного фото убран кадрированием.</a:t>
             </a:r>
           </a:p>
         </p:txBody>
@@ -4902,7 +4902,7 @@
       </p:sp>
       <p:pic>
         <p:nvPicPr>
-          <p:cNvPr id="6" name="PHOTO SLOT — G 63 carbon ceramic" descr="slot_g63.jpg"/>
+          <p:cNvPr id="6" name="Photo — G 63 carbon ceramic" descr="brake_g63.jpg"/>
           <p:cNvPicPr>
             <a:picLocks noChangeAspect="1"/>
           </p:cNvPicPr>
@@ -4916,8 +4916,8 @@
         </p:blipFill>
         <p:spPr>
           <a:xfrm>
-            <a:off x="0" y="2921000"/>
-            <a:ext cx="6858000" cy="4064000"/>
+            <a:off x="0" y="2794000"/>
+            <a:ext cx="6858000" cy="4572000"/>
           </a:xfrm>
           <a:prstGeom prst="rect">
             <a:avLst/>
@@ -4932,7 +4932,7 @@
         </p:nvSpPr>
         <p:spPr>
           <a:xfrm>
-            <a:off x="0" y="2921000"/>
+            <a:off x="0" y="2794000"/>
             <a:ext cx="6858000" cy="6350"/>
           </a:xfrm>
           <a:prstGeom prst="rect">
@@ -4978,7 +4978,7 @@
         </p:nvSpPr>
         <p:spPr>
           <a:xfrm>
-            <a:off x="0" y="6985000"/>
+            <a:off x="0" y="7366000"/>
             <a:ext cx="6858000" cy="6350"/>
           </a:xfrm>
           <a:prstGeom prst="rect">
@@ -5024,8 +5024,8 @@
         </p:nvSpPr>
         <p:spPr>
           <a:xfrm>
-            <a:off x="533400" y="7277100"/>
-            <a:ext cx="5842000" cy="2667000"/>
+            <a:off x="533400" y="7594600"/>
+            <a:ext cx="5842000" cy="2540000"/>
           </a:xfrm>
           <a:prstGeom prst="rect">
             <a:avLst/>
@@ -5080,7 +5080,7 @@
         </p:nvSpPr>
         <p:spPr>
           <a:xfrm>
-            <a:off x="533400" y="10096500"/>
+            <a:off x="533400" y="10223500"/>
             <a:ext cx="762000" cy="6350"/>
           </a:xfrm>
           <a:prstGeom prst="rect">
@@ -5126,7 +5126,7 @@
         </p:nvSpPr>
         <p:spPr>
           <a:xfrm>
-            <a:off x="533400" y="10261600"/>
+            <a:off x="533400" y="10375900"/>
             <a:ext cx="5791200" cy="952500"/>
           </a:xfrm>
           <a:prstGeom prst="rect">
@@ -11979,13 +11979,59 @@
       </p:sp>
       <p:sp>
         <p:nvSpPr>
-          <p:cNvPr id="6" name="TextBox 5"/>
+          <p:cNvPr id="6" name="Rectangle 5"/>
+          <p:cNvSpPr/>
+          <p:nvPr/>
+        </p:nvSpPr>
+        <p:spPr>
+          <a:xfrm>
+            <a:off x="533400" y="2667000"/>
+            <a:ext cx="419100" cy="279400"/>
+          </a:xfrm>
+          <a:prstGeom prst="rect">
+            <a:avLst/>
+          </a:prstGeom>
+          <a:solidFill>
+            <a:srgbClr val="0B0D10">
+              <a:alpha val="62000"/>
+            </a:srgbClr>
+          </a:solidFill>
+          <a:ln>
+            <a:noFill/>
+          </a:ln>
+          <a:effectLst/>
+        </p:spPr>
+        <p:style>
+          <a:lnRef idx="1">
+            <a:schemeClr val="accent1"/>
+          </a:lnRef>
+          <a:fillRef idx="3">
+            <a:schemeClr val="accent1"/>
+          </a:fillRef>
+          <a:effectRef idx="2">
+            <a:schemeClr val="accent1"/>
+          </a:effectRef>
+          <a:fontRef idx="minor">
+            <a:schemeClr val="lt1"/>
+          </a:fontRef>
+        </p:style>
+        <p:txBody>
+          <a:bodyPr rtlCol="0" anchor="ctr"/>
+          <a:lstStyle/>
+          <a:p>
+            <a:pPr algn="ctr"/>
+          </a:p>
+        </p:txBody>
+      </p:sp>
+      <p:sp>
+        <p:nvSpPr>
+          <p:cNvPr id="7" name="TextBox 6"/>
           <p:cNvSpPr txBox="1"/>
           <p:nvPr/>
         </p:nvSpPr>
         <p:spPr>
           <a:xfrm>
-            <a:off x="647700" y="3390900"/>
+            <a:off x="635000" y="2724150"/>
             <a:ext cx="508000" cy="190500"/>
           </a:xfrm>
           <a:prstGeom prst="rect">
@@ -12020,13 +12066,59 @@
       </p:sp>
       <p:sp>
         <p:nvSpPr>
-          <p:cNvPr id="7" name="TextBox 6"/>
+          <p:cNvPr id="8" name="Rectangle 7"/>
+          <p:cNvSpPr/>
+          <p:nvPr/>
+        </p:nvSpPr>
+        <p:spPr>
+          <a:xfrm>
+            <a:off x="533400" y="7588250"/>
+            <a:ext cx="419100" cy="279400"/>
+          </a:xfrm>
+          <a:prstGeom prst="rect">
+            <a:avLst/>
+          </a:prstGeom>
+          <a:solidFill>
+            <a:srgbClr val="0B0D10">
+              <a:alpha val="62000"/>
+            </a:srgbClr>
+          </a:solidFill>
+          <a:ln>
+            <a:noFill/>
+          </a:ln>
+          <a:effectLst/>
+        </p:spPr>
+        <p:style>
+          <a:lnRef idx="1">
+            <a:schemeClr val="accent1"/>
+          </a:lnRef>
+          <a:fillRef idx="3">
+            <a:schemeClr val="accent1"/>
+          </a:fillRef>
+          <a:effectRef idx="2">
+            <a:schemeClr val="accent1"/>
+          </a:effectRef>
+          <a:fontRef idx="minor">
+            <a:schemeClr val="lt1"/>
+          </a:fontRef>
+        </p:style>
+        <p:txBody>
+          <a:bodyPr rtlCol="0" anchor="ctr"/>
+          <a:lstStyle/>
+          <a:p>
+            <a:pPr algn="ctr"/>
+          </a:p>
+        </p:txBody>
+      </p:sp>
+      <p:sp>
+        <p:nvSpPr>
+          <p:cNvPr id="9" name="TextBox 8"/>
           <p:cNvSpPr txBox="1"/>
           <p:nvPr/>
         </p:nvSpPr>
         <p:spPr>
           <a:xfrm>
-            <a:off x="4508500" y="3390900"/>
+            <a:off x="635000" y="7645400"/>
             <a:ext cx="508000" cy="190500"/>
           </a:xfrm>
           <a:prstGeom prst="rect">
@@ -12061,13 +12153,59 @@
       </p:sp>
       <p:sp>
         <p:nvSpPr>
-          <p:cNvPr id="8" name="TextBox 7"/>
+          <p:cNvPr id="10" name="Rectangle 9"/>
+          <p:cNvSpPr/>
+          <p:nvPr/>
+        </p:nvSpPr>
+        <p:spPr>
+          <a:xfrm>
+            <a:off x="2514600" y="7588250"/>
+            <a:ext cx="419100" cy="279400"/>
+          </a:xfrm>
+          <a:prstGeom prst="rect">
+            <a:avLst/>
+          </a:prstGeom>
+          <a:solidFill>
+            <a:srgbClr val="0B0D10">
+              <a:alpha val="62000"/>
+            </a:srgbClr>
+          </a:solidFill>
+          <a:ln>
+            <a:noFill/>
+          </a:ln>
+          <a:effectLst/>
+        </p:spPr>
+        <p:style>
+          <a:lnRef idx="1">
+            <a:schemeClr val="accent1"/>
+          </a:lnRef>
+          <a:fillRef idx="3">
+            <a:schemeClr val="accent1"/>
+          </a:fillRef>
+          <a:effectRef idx="2">
+            <a:schemeClr val="accent1"/>
+          </a:effectRef>
+          <a:fontRef idx="minor">
+            <a:schemeClr val="lt1"/>
+          </a:fontRef>
+        </p:style>
+        <p:txBody>
+          <a:bodyPr rtlCol="0" anchor="ctr"/>
+          <a:lstStyle/>
+          <a:p>
+            <a:pPr algn="ctr"/>
+          </a:p>
+        </p:txBody>
+      </p:sp>
+      <p:sp>
+        <p:nvSpPr>
+          <p:cNvPr id="11" name="TextBox 10"/>
           <p:cNvSpPr txBox="1"/>
           <p:nvPr/>
         </p:nvSpPr>
         <p:spPr>
           <a:xfrm>
-            <a:off x="4508500" y="5137150"/>
+            <a:off x="2616200" y="7645400"/>
             <a:ext cx="508000" cy="190500"/>
           </a:xfrm>
           <a:prstGeom prst="rect">
@@ -12102,13 +12240,59 @@
       </p:sp>
       <p:sp>
         <p:nvSpPr>
-          <p:cNvPr id="9" name="TextBox 8"/>
+          <p:cNvPr id="12" name="Rectangle 11"/>
+          <p:cNvSpPr/>
+          <p:nvPr/>
+        </p:nvSpPr>
+        <p:spPr>
+          <a:xfrm>
+            <a:off x="4495800" y="7588250"/>
+            <a:ext cx="419100" cy="279400"/>
+          </a:xfrm>
+          <a:prstGeom prst="rect">
+            <a:avLst/>
+          </a:prstGeom>
+          <a:solidFill>
+            <a:srgbClr val="0B0D10">
+              <a:alpha val="62000"/>
+            </a:srgbClr>
+          </a:solidFill>
+          <a:ln>
+            <a:noFill/>
+          </a:ln>
+          <a:effectLst/>
+        </p:spPr>
+        <p:style>
+          <a:lnRef idx="1">
+            <a:schemeClr val="accent1"/>
+          </a:lnRef>
+          <a:fillRef idx="3">
+            <a:schemeClr val="accent1"/>
+          </a:fillRef>
+          <a:effectRef idx="2">
+            <a:schemeClr val="accent1"/>
+          </a:effectRef>
+          <a:fontRef idx="minor">
+            <a:schemeClr val="lt1"/>
+          </a:fontRef>
+        </p:style>
+        <p:txBody>
+          <a:bodyPr rtlCol="0" anchor="ctr"/>
+          <a:lstStyle/>
+          <a:p>
+            <a:pPr algn="ctr"/>
+          </a:p>
+        </p:txBody>
+      </p:sp>
+      <p:sp>
+        <p:nvSpPr>
+          <p:cNvPr id="13" name="TextBox 12"/>
           <p:cNvSpPr txBox="1"/>
           <p:nvPr/>
         </p:nvSpPr>
         <p:spPr>
           <a:xfrm>
-            <a:off x="4508500" y="6883400"/>
+            <a:off x="4597400" y="7645400"/>
             <a:ext cx="508000" cy="190500"/>
           </a:xfrm>
           <a:prstGeom prst="rect">
@@ -12143,13 +12327,13 @@
       </p:sp>
       <p:sp>
         <p:nvSpPr>
-          <p:cNvPr id="10" name="Rectangle 9"/>
+          <p:cNvPr id="14" name="Rectangle 13"/>
           <p:cNvSpPr/>
           <p:nvPr/>
         </p:nvSpPr>
         <p:spPr>
           <a:xfrm>
-            <a:off x="533400" y="8775700"/>
+            <a:off x="533400" y="9258300"/>
             <a:ext cx="5791200" cy="6350"/>
           </a:xfrm>
           <a:prstGeom prst="rect">
@@ -12189,13 +12373,13 @@
       </p:sp>
       <p:sp>
         <p:nvSpPr>
-          <p:cNvPr id="11" name="TextBox 10"/>
+          <p:cNvPr id="15" name="TextBox 14"/>
           <p:cNvSpPr txBox="1"/>
           <p:nvPr/>
         </p:nvSpPr>
         <p:spPr>
           <a:xfrm>
-            <a:off x="533400" y="8902700"/>
+            <a:off x="533400" y="9372600"/>
             <a:ext cx="571500" cy="254000"/>
           </a:xfrm>
           <a:prstGeom prst="rect">
@@ -12230,14 +12414,14 @@
       </p:sp>
       <p:sp>
         <p:nvSpPr>
-          <p:cNvPr id="12" name="TextBox 11"/>
+          <p:cNvPr id="16" name="TextBox 15"/>
           <p:cNvSpPr txBox="1"/>
           <p:nvPr/>
         </p:nvSpPr>
         <p:spPr>
           <a:xfrm>
-            <a:off x="1206500" y="8864600"/>
-            <a:ext cx="3175000" cy="279400"/>
+            <a:off x="1206500" y="9321800"/>
+            <a:ext cx="4445000" cy="279400"/>
           </a:xfrm>
           <a:prstGeom prst="rect">
             <a:avLst/>
@@ -12264,21 +12448,21 @@
                 <a:ea typeface="Montserrat Medium"/>
                 <a:cs typeface="Montserrat Medium"/>
               </a:rPr>
-              <a:t>Многоспицевый</a:t>
-            </a:r>
-          </a:p>
-        </p:txBody>
-      </p:sp>
-      <p:sp>
-        <p:nvSpPr>
-          <p:cNvPr id="13" name="TextBox 12"/>
+              <a:t>Кованый комплект</a:t>
+            </a:r>
+          </a:p>
+        </p:txBody>
+      </p:sp>
+      <p:sp>
+        <p:nvSpPr>
+          <p:cNvPr id="17" name="TextBox 16"/>
           <p:cNvSpPr txBox="1"/>
           <p:nvPr/>
         </p:nvSpPr>
         <p:spPr>
           <a:xfrm>
-            <a:off x="1206500" y="9118600"/>
-            <a:ext cx="4445000" cy="215900"/>
+            <a:off x="1206500" y="9550400"/>
+            <a:ext cx="4953000" cy="215900"/>
           </a:xfrm>
           <a:prstGeom prst="rect">
             <a:avLst/>
@@ -12305,20 +12489,20 @@
                 <a:ea typeface="Montserrat Light"/>
                 <a:cs typeface="Montserrat Light"/>
               </a:rPr>
-              <a:t>турбинный рисунок</a:t>
-            </a:r>
-          </a:p>
-        </p:txBody>
-      </p:sp>
-      <p:sp>
-        <p:nvSpPr>
-          <p:cNvPr id="14" name="Rectangle 13"/>
+              <a:t>чёрный лак, контрастная кромка</a:t>
+            </a:r>
+          </a:p>
+        </p:txBody>
+      </p:sp>
+      <p:sp>
+        <p:nvSpPr>
+          <p:cNvPr id="18" name="Rectangle 17"/>
           <p:cNvSpPr/>
           <p:nvPr/>
         </p:nvSpPr>
         <p:spPr>
           <a:xfrm>
-            <a:off x="533400" y="9410700"/>
+            <a:off x="533400" y="9817100"/>
             <a:ext cx="5791200" cy="6350"/>
           </a:xfrm>
           <a:prstGeom prst="rect">
@@ -12358,13 +12542,13 @@
       </p:sp>
       <p:sp>
         <p:nvSpPr>
-          <p:cNvPr id="15" name="TextBox 14"/>
+          <p:cNvPr id="19" name="TextBox 18"/>
           <p:cNvSpPr txBox="1"/>
           <p:nvPr/>
         </p:nvSpPr>
         <p:spPr>
           <a:xfrm>
-            <a:off x="533400" y="9537700"/>
+            <a:off x="533400" y="9931400"/>
             <a:ext cx="571500" cy="254000"/>
           </a:xfrm>
           <a:prstGeom prst="rect">
@@ -12399,14 +12583,14 @@
       </p:sp>
       <p:sp>
         <p:nvSpPr>
-          <p:cNvPr id="16" name="TextBox 15"/>
+          <p:cNvPr id="20" name="TextBox 19"/>
           <p:cNvSpPr txBox="1"/>
           <p:nvPr/>
         </p:nvSpPr>
         <p:spPr>
           <a:xfrm>
-            <a:off x="1206500" y="9499600"/>
-            <a:ext cx="3175000" cy="279400"/>
+            <a:off x="1206500" y="9880600"/>
+            <a:ext cx="4445000" cy="279400"/>
           </a:xfrm>
           <a:prstGeom prst="rect">
             <a:avLst/>
@@ -12433,21 +12617,21 @@
                 <a:ea typeface="Montserrat Medium"/>
                 <a:cs typeface="Montserrat Medium"/>
               </a:rPr>
-              <a:t>Массивный моноблок</a:t>
-            </a:r>
-          </a:p>
-        </p:txBody>
-      </p:sp>
-      <p:sp>
-        <p:nvSpPr>
-          <p:cNvPr id="17" name="TextBox 16"/>
+              <a:t>Многоспицевый</a:t>
+            </a:r>
+          </a:p>
+        </p:txBody>
+      </p:sp>
+      <p:sp>
+        <p:nvSpPr>
+          <p:cNvPr id="21" name="TextBox 20"/>
           <p:cNvSpPr txBox="1"/>
           <p:nvPr/>
         </p:nvSpPr>
         <p:spPr>
           <a:xfrm>
-            <a:off x="1206500" y="9753600"/>
-            <a:ext cx="4445000" cy="215900"/>
+            <a:off x="1206500" y="10109200"/>
+            <a:ext cx="4953000" cy="215900"/>
           </a:xfrm>
           <a:prstGeom prst="rect">
             <a:avLst/>
@@ -12474,20 +12658,20 @@
                 <a:ea typeface="Montserrat Light"/>
                 <a:cs typeface="Montserrat Light"/>
               </a:rPr>
-              <a:t>чёрный лак, полированная кромка</a:t>
-            </a:r>
-          </a:p>
-        </p:txBody>
-      </p:sp>
-      <p:sp>
-        <p:nvSpPr>
-          <p:cNvPr id="18" name="Rectangle 17"/>
+              <a:t>турбинный рисунок</a:t>
+            </a:r>
+          </a:p>
+        </p:txBody>
+      </p:sp>
+      <p:sp>
+        <p:nvSpPr>
+          <p:cNvPr id="22" name="Rectangle 21"/>
           <p:cNvSpPr/>
           <p:nvPr/>
         </p:nvSpPr>
         <p:spPr>
           <a:xfrm>
-            <a:off x="533400" y="10045700"/>
+            <a:off x="533400" y="10375900"/>
             <a:ext cx="5791200" cy="6350"/>
           </a:xfrm>
           <a:prstGeom prst="rect">
@@ -12527,13 +12711,13 @@
       </p:sp>
       <p:sp>
         <p:nvSpPr>
-          <p:cNvPr id="19" name="TextBox 18"/>
+          <p:cNvPr id="23" name="TextBox 22"/>
           <p:cNvSpPr txBox="1"/>
           <p:nvPr/>
         </p:nvSpPr>
         <p:spPr>
           <a:xfrm>
-            <a:off x="533400" y="10172700"/>
+            <a:off x="533400" y="10490200"/>
             <a:ext cx="571500" cy="254000"/>
           </a:xfrm>
           <a:prstGeom prst="rect">
@@ -12568,14 +12752,14 @@
       </p:sp>
       <p:sp>
         <p:nvSpPr>
-          <p:cNvPr id="20" name="TextBox 19"/>
+          <p:cNvPr id="24" name="TextBox 23"/>
           <p:cNvSpPr txBox="1"/>
           <p:nvPr/>
         </p:nvSpPr>
         <p:spPr>
           <a:xfrm>
-            <a:off x="1206500" y="10134600"/>
-            <a:ext cx="3175000" cy="279400"/>
+            <a:off x="1206500" y="10439400"/>
+            <a:ext cx="4445000" cy="279400"/>
           </a:xfrm>
           <a:prstGeom prst="rect">
             <a:avLst/>
@@ -12609,14 +12793,14 @@
       </p:sp>
       <p:sp>
         <p:nvSpPr>
-          <p:cNvPr id="21" name="TextBox 20"/>
+          <p:cNvPr id="25" name="TextBox 24"/>
           <p:cNvSpPr txBox="1"/>
           <p:nvPr/>
         </p:nvSpPr>
         <p:spPr>
           <a:xfrm>
-            <a:off x="1206500" y="10388600"/>
-            <a:ext cx="4445000" cy="215900"/>
+            <a:off x="1206500" y="10668000"/>
+            <a:ext cx="4953000" cy="215900"/>
           </a:xfrm>
           <a:prstGeom prst="rect">
             <a:avLst/>
@@ -12650,13 +12834,13 @@
       </p:sp>
       <p:sp>
         <p:nvSpPr>
-          <p:cNvPr id="22" name="Rectangle 21"/>
+          <p:cNvPr id="26" name="Rectangle 25"/>
           <p:cNvSpPr/>
           <p:nvPr/>
         </p:nvSpPr>
         <p:spPr>
           <a:xfrm>
-            <a:off x="533400" y="10680700"/>
+            <a:off x="533400" y="10934700"/>
             <a:ext cx="5791200" cy="6350"/>
           </a:xfrm>
           <a:prstGeom prst="rect">
@@ -12696,13 +12880,13 @@
       </p:sp>
       <p:sp>
         <p:nvSpPr>
-          <p:cNvPr id="23" name="TextBox 22"/>
+          <p:cNvPr id="27" name="TextBox 26"/>
           <p:cNvSpPr txBox="1"/>
           <p:nvPr/>
         </p:nvSpPr>
         <p:spPr>
           <a:xfrm>
-            <a:off x="533400" y="10807700"/>
+            <a:off x="533400" y="11049000"/>
             <a:ext cx="571500" cy="254000"/>
           </a:xfrm>
           <a:prstGeom prst="rect">
@@ -12737,14 +12921,14 @@
       </p:sp>
       <p:sp>
         <p:nvSpPr>
-          <p:cNvPr id="24" name="TextBox 23"/>
+          <p:cNvPr id="28" name="TextBox 27"/>
           <p:cNvSpPr txBox="1"/>
           <p:nvPr/>
         </p:nvSpPr>
         <p:spPr>
           <a:xfrm>
-            <a:off x="1206500" y="10769600"/>
-            <a:ext cx="3175000" cy="279400"/>
+            <a:off x="1206500" y="10998200"/>
+            <a:ext cx="4445000" cy="279400"/>
           </a:xfrm>
           <a:prstGeom prst="rect">
             <a:avLst/>
@@ -12771,21 +12955,21 @@
                 <a:ea typeface="Montserrat Medium"/>
                 <a:cs typeface="Montserrat Medium"/>
               </a:rPr>
-              <a:t>Спортивный</a:t>
-            </a:r>
-          </a:p>
-        </p:txBody>
-      </p:sp>
-      <p:sp>
-        <p:nvSpPr>
-          <p:cNvPr id="25" name="TextBox 24"/>
+              <a:t>Массивный моноблок</a:t>
+            </a:r>
+          </a:p>
+        </p:txBody>
+      </p:sp>
+      <p:sp>
+        <p:nvSpPr>
+          <p:cNvPr id="29" name="TextBox 28"/>
           <p:cNvSpPr txBox="1"/>
           <p:nvPr/>
         </p:nvSpPr>
         <p:spPr>
           <a:xfrm>
-            <a:off x="1206500" y="11023600"/>
-            <a:ext cx="4445000" cy="215900"/>
+            <a:off x="1206500" y="11226800"/>
+            <a:ext cx="4953000" cy="215900"/>
           </a:xfrm>
           <a:prstGeom prst="rect">
             <a:avLst/>
@@ -12812,14 +12996,14 @@
                 <a:ea typeface="Montserrat Light"/>
                 <a:cs typeface="Montserrat Light"/>
               </a:rPr>
-              <a:t>пять лучей, широкий вылет</a:t>
-            </a:r>
-          </a:p>
-        </p:txBody>
-      </p:sp>
-      <p:sp>
-        <p:nvSpPr>
-          <p:cNvPr id="26" name="TextBox 25"/>
+              <a:t>чёрный лак, полированная кромка</a:t>
+            </a:r>
+          </a:p>
+        </p:txBody>
+      </p:sp>
+      <p:sp>
+        <p:nvSpPr>
+          <p:cNvPr id="30" name="TextBox 29"/>
           <p:cNvSpPr txBox="1"/>
           <p:nvPr/>
         </p:nvSpPr>
@@ -12860,7 +13044,7 @@
       </p:sp>
       <p:sp>
         <p:nvSpPr>
-          <p:cNvPr id="27" name="Rectangle 26"/>
+          <p:cNvPr id="31" name="Rectangle 30"/>
           <p:cNvSpPr/>
           <p:nvPr/>
         </p:nvSpPr>
@@ -12904,7 +13088,7 @@
       </p:sp>
       <p:sp>
         <p:nvSpPr>
-          <p:cNvPr id="28" name="TextBox 27"/>
+          <p:cNvPr id="32" name="TextBox 31"/>
           <p:cNvSpPr txBox="1"/>
           <p:nvPr/>
         </p:nvSpPr>
@@ -13787,7 +13971,7 @@
       <p:grpSpPr/>
       <p:pic>
         <p:nvPicPr>
-          <p:cNvPr id="2" name="PHOTO SLOT — G-Class" descr="slot_gclass.jpg"/>
+          <p:cNvPr id="2" name="Picture 1" descr="bg08.jpg"/>
           <p:cNvPicPr>
             <a:picLocks noChangeAspect="1"/>
           </p:cNvPicPr>
@@ -13809,33 +13993,9 @@
           </a:prstGeom>
         </p:spPr>
       </p:pic>
-      <p:pic>
-        <p:nvPicPr>
-          <p:cNvPr id="3" name="shade" descr="ov08.png"/>
-          <p:cNvPicPr>
-            <a:picLocks noChangeAspect="1"/>
-          </p:cNvPicPr>
-          <p:nvPr/>
-        </p:nvPicPr>
-        <p:blipFill>
-          <a:blip r:embed="rId3"/>
-          <a:stretch>
-            <a:fillRect/>
-          </a:stretch>
-        </p:blipFill>
-        <p:spPr>
-          <a:xfrm>
-            <a:off x="0" y="0"/>
-            <a:ext cx="6858000" cy="12192000"/>
-          </a:xfrm>
-          <a:prstGeom prst="rect">
-            <a:avLst/>
-          </a:prstGeom>
-        </p:spPr>
-      </p:pic>
-      <p:sp>
-        <p:nvSpPr>
-          <p:cNvPr id="4" name="Rectangle 3"/>
+      <p:sp>
+        <p:nvSpPr>
+          <p:cNvPr id="3" name="Rectangle 2"/>
           <p:cNvSpPr/>
           <p:nvPr/>
         </p:nvSpPr>
@@ -13879,7 +14039,7 @@
       </p:sp>
       <p:sp>
         <p:nvSpPr>
-          <p:cNvPr id="5" name="TextBox 4"/>
+          <p:cNvPr id="4" name="TextBox 3"/>
           <p:cNvSpPr txBox="1"/>
           <p:nvPr/>
         </p:nvSpPr>
@@ -13920,13 +14080,13 @@
       </p:sp>
       <p:sp>
         <p:nvSpPr>
-          <p:cNvPr id="6" name="Title"/>
+          <p:cNvPr id="5" name="Title"/>
           <p:cNvSpPr txBox="1"/>
           <p:nvPr/>
         </p:nvSpPr>
         <p:spPr>
           <a:xfrm>
-            <a:off x="533400" y="8763000"/>
+            <a:off x="533400" y="8255000"/>
             <a:ext cx="5842000" cy="1524000"/>
           </a:xfrm>
           <a:prstGeom prst="rect">
@@ -13985,13 +14145,13 @@
       </p:sp>
       <p:sp>
         <p:nvSpPr>
-          <p:cNvPr id="7" name="TextBox 6"/>
+          <p:cNvPr id="6" name="TextBox 5"/>
           <p:cNvSpPr txBox="1"/>
           <p:nvPr/>
         </p:nvSpPr>
         <p:spPr>
           <a:xfrm>
-            <a:off x="533400" y="10350500"/>
+            <a:off x="533400" y="9842500"/>
             <a:ext cx="4572000" cy="635000"/>
           </a:xfrm>
           <a:prstGeom prst="rect">
@@ -14029,7 +14189,7 @@
       </p:sp>
       <p:sp>
         <p:nvSpPr>
-          <p:cNvPr id="8" name="TextBox 7"/>
+          <p:cNvPr id="7" name="TextBox 6"/>
           <p:cNvSpPr txBox="1"/>
           <p:nvPr/>
         </p:nvSpPr>
@@ -14070,7 +14230,7 @@
       </p:sp>
       <p:sp>
         <p:nvSpPr>
-          <p:cNvPr id="9" name="Rectangle 8"/>
+          <p:cNvPr id="8" name="Rectangle 7"/>
           <p:cNvSpPr/>
           <p:nvPr/>
         </p:nvSpPr>
@@ -14114,7 +14274,7 @@
       </p:sp>
       <p:sp>
         <p:nvSpPr>
-          <p:cNvPr id="10" name="TextBox 9"/>
+          <p:cNvPr id="9" name="TextBox 8"/>
           <p:cNvSpPr txBox="1"/>
           <p:nvPr/>
         </p:nvSpPr>
@@ -14400,7 +14560,7 @@
       </p:sp>
       <p:pic>
         <p:nvPicPr>
-          <p:cNvPr id="6" name="PHOTO SLOT — brakes" descr="slot_brakes.jpg"/>
+          <p:cNvPr id="6" name="Photo — brake set" descr="brakes_set.jpg"/>
           <p:cNvPicPr>
             <a:picLocks noChangeAspect="1"/>
           </p:cNvPicPr>
@@ -14430,8 +14590,8 @@
         </p:nvSpPr>
         <p:spPr>
           <a:xfrm>
-            <a:off x="533400" y="9969500"/>
-            <a:ext cx="1778000" cy="6350"/>
+            <a:off x="0" y="4064000"/>
+            <a:ext cx="6858000" cy="6350"/>
           </a:xfrm>
           <a:prstGeom prst="rect">
             <a:avLst/>
@@ -14470,99 +14630,14 @@
       </p:sp>
       <p:sp>
         <p:nvSpPr>
-          <p:cNvPr id="8" name="TextBox 7"/>
-          <p:cNvSpPr txBox="1"/>
-          <p:nvPr/>
-        </p:nvSpPr>
-        <p:spPr>
-          <a:xfrm>
-            <a:off x="533400" y="10109200"/>
-            <a:ext cx="1778000" cy="190500"/>
-          </a:xfrm>
-          <a:prstGeom prst="rect">
-            <a:avLst/>
-          </a:prstGeom>
-          <a:noFill/>
-        </p:spPr>
-        <p:txBody>
-          <a:bodyPr wrap="square" lIns="0" rIns="0" tIns="0" bIns="0" anchor="t">
-            <a:noAutofit/>
-          </a:bodyPr>
-          <a:lstStyle/>
-          <a:p>
-            <a:pPr algn="l">
-              <a:spcBef>
-                <a:spcPts val="0"/>
-              </a:spcBef>
-            </a:pPr>
-            <a:r>
-              <a:rPr sz="1000" lang="ru-RU" spc="200">
-                <a:solidFill>
-                  <a:srgbClr val="8C939A"/>
-                </a:solidFill>
-                <a:latin typeface="Montserrat Medium"/>
-                <a:ea typeface="Montserrat Medium"/>
-                <a:cs typeface="Montserrat Medium"/>
-              </a:rPr>
-              <a:t>СУППОРТЫ</a:t>
-            </a:r>
-          </a:p>
-        </p:txBody>
-      </p:sp>
-      <p:sp>
-        <p:nvSpPr>
-          <p:cNvPr id="9" name="TextBox 8"/>
-          <p:cNvSpPr txBox="1"/>
-          <p:nvPr/>
-        </p:nvSpPr>
-        <p:spPr>
-          <a:xfrm>
-            <a:off x="533400" y="10350500"/>
-            <a:ext cx="1866900" cy="508000"/>
-          </a:xfrm>
-          <a:prstGeom prst="rect">
-            <a:avLst/>
-          </a:prstGeom>
-          <a:noFill/>
-        </p:spPr>
-        <p:txBody>
-          <a:bodyPr wrap="square" lIns="0" rIns="0" tIns="0" bIns="0" anchor="t">
-            <a:noAutofit/>
-          </a:bodyPr>
-          <a:lstStyle/>
-          <a:p>
-            <a:pPr algn="l">
-              <a:lnSpc>
-                <a:spcPts val="2000"/>
-              </a:lnSpc>
-              <a:spcBef>
-                <a:spcPts val="0"/>
-              </a:spcBef>
-            </a:pPr>
-            <a:r>
-              <a:rPr sz="1600" lang="ru-RU">
-                <a:solidFill>
-                  <a:srgbClr val="FFFFFF"/>
-                </a:solidFill>
-                <a:latin typeface="Montserrat Light"/>
-                <a:ea typeface="Montserrat Light"/>
-                <a:cs typeface="Montserrat Light"/>
-              </a:rPr>
-              <a:t>AMG</a:t>
-            </a:r>
-          </a:p>
-        </p:txBody>
-      </p:sp>
-      <p:sp>
-        <p:nvSpPr>
-          <p:cNvPr id="10" name="Rectangle 9"/>
+          <p:cNvPr id="8" name="Rectangle 7"/>
           <p:cNvSpPr/>
           <p:nvPr/>
         </p:nvSpPr>
         <p:spPr>
           <a:xfrm>
-            <a:off x="2463800" y="9969500"/>
-            <a:ext cx="1778000" cy="6350"/>
+            <a:off x="0" y="9525000"/>
+            <a:ext cx="6858000" cy="6350"/>
           </a:xfrm>
           <a:prstGeom prst="rect">
             <a:avLst/>
@@ -14601,98 +14676,13 @@
       </p:sp>
       <p:sp>
         <p:nvSpPr>
-          <p:cNvPr id="11" name="TextBox 10"/>
-          <p:cNvSpPr txBox="1"/>
-          <p:nvPr/>
-        </p:nvSpPr>
-        <p:spPr>
-          <a:xfrm>
-            <a:off x="2463800" y="10109200"/>
-            <a:ext cx="1778000" cy="190500"/>
-          </a:xfrm>
-          <a:prstGeom prst="rect">
-            <a:avLst/>
-          </a:prstGeom>
-          <a:noFill/>
-        </p:spPr>
-        <p:txBody>
-          <a:bodyPr wrap="square" lIns="0" rIns="0" tIns="0" bIns="0" anchor="t">
-            <a:noAutofit/>
-          </a:bodyPr>
-          <a:lstStyle/>
-          <a:p>
-            <a:pPr algn="l">
-              <a:spcBef>
-                <a:spcPts val="0"/>
-              </a:spcBef>
-            </a:pPr>
-            <a:r>
-              <a:rPr sz="1000" lang="ru-RU" spc="200">
-                <a:solidFill>
-                  <a:srgbClr val="8C939A"/>
-                </a:solidFill>
-                <a:latin typeface="Montserrat Medium"/>
-                <a:ea typeface="Montserrat Medium"/>
-                <a:cs typeface="Montserrat Medium"/>
-              </a:rPr>
-              <a:t>ДИСКИ</a:t>
-            </a:r>
-          </a:p>
-        </p:txBody>
-      </p:sp>
-      <p:sp>
-        <p:nvSpPr>
-          <p:cNvPr id="12" name="TextBox 11"/>
-          <p:cNvSpPr txBox="1"/>
-          <p:nvPr/>
-        </p:nvSpPr>
-        <p:spPr>
-          <a:xfrm>
-            <a:off x="2463800" y="10350500"/>
-            <a:ext cx="1866900" cy="508000"/>
-          </a:xfrm>
-          <a:prstGeom prst="rect">
-            <a:avLst/>
-          </a:prstGeom>
-          <a:noFill/>
-        </p:spPr>
-        <p:txBody>
-          <a:bodyPr wrap="square" lIns="0" rIns="0" tIns="0" bIns="0" anchor="t">
-            <a:noAutofit/>
-          </a:bodyPr>
-          <a:lstStyle/>
-          <a:p>
-            <a:pPr algn="l">
-              <a:lnSpc>
-                <a:spcPts val="2000"/>
-              </a:lnSpc>
-              <a:spcBef>
-                <a:spcPts val="0"/>
-              </a:spcBef>
-            </a:pPr>
-            <a:r>
-              <a:rPr sz="1600" lang="ru-RU">
-                <a:solidFill>
-                  <a:srgbClr val="FFFFFF"/>
-                </a:solidFill>
-                <a:latin typeface="Montserrat Light"/>
-                <a:ea typeface="Montserrat Light"/>
-                <a:cs typeface="Montserrat Light"/>
-              </a:rPr>
-              <a:t>Карбон-керамика</a:t>
-            </a:r>
-          </a:p>
-        </p:txBody>
-      </p:sp>
-      <p:sp>
-        <p:nvSpPr>
-          <p:cNvPr id="13" name="Rectangle 12"/>
+          <p:cNvPr id="9" name="Rectangle 8"/>
           <p:cNvSpPr/>
           <p:nvPr/>
         </p:nvSpPr>
         <p:spPr>
           <a:xfrm>
-            <a:off x="4394200" y="9969500"/>
+            <a:off x="533400" y="9969500"/>
             <a:ext cx="1778000" cy="6350"/>
           </a:xfrm>
           <a:prstGeom prst="rect">
@@ -14732,13 +14722,13 @@
       </p:sp>
       <p:sp>
         <p:nvSpPr>
-          <p:cNvPr id="14" name="TextBox 13"/>
+          <p:cNvPr id="10" name="TextBox 9"/>
           <p:cNvSpPr txBox="1"/>
           <p:nvPr/>
         </p:nvSpPr>
         <p:spPr>
           <a:xfrm>
-            <a:off x="4394200" y="10109200"/>
+            <a:off x="533400" y="10109200"/>
             <a:ext cx="1778000" cy="190500"/>
           </a:xfrm>
           <a:prstGeom prst="rect">
@@ -14766,20 +14756,20 @@
                 <a:ea typeface="Montserrat Medium"/>
                 <a:cs typeface="Montserrat Medium"/>
               </a:rPr>
-              <a:t>КОМПОНЕНТЫ</a:t>
-            </a:r>
-          </a:p>
-        </p:txBody>
-      </p:sp>
-      <p:sp>
-        <p:nvSpPr>
-          <p:cNvPr id="15" name="TextBox 14"/>
+              <a:t>СУППОРТЫ</a:t>
+            </a:r>
+          </a:p>
+        </p:txBody>
+      </p:sp>
+      <p:sp>
+        <p:nvSpPr>
+          <p:cNvPr id="11" name="TextBox 10"/>
           <p:cNvSpPr txBox="1"/>
           <p:nvPr/>
         </p:nvSpPr>
         <p:spPr>
           <a:xfrm>
-            <a:off x="4394200" y="10350500"/>
+            <a:off x="533400" y="10350500"/>
             <a:ext cx="1866900" cy="508000"/>
           </a:xfrm>
           <a:prstGeom prst="rect">
@@ -14810,21 +14800,67 @@
                 <a:ea typeface="Montserrat Light"/>
                 <a:cs typeface="Montserrat Light"/>
               </a:rPr>
-              <a:t>Оригинальные</a:t>
-            </a:r>
-          </a:p>
-        </p:txBody>
-      </p:sp>
-      <p:sp>
-        <p:nvSpPr>
-          <p:cNvPr id="16" name="TextBox 15"/>
+              <a:t>AMG</a:t>
+            </a:r>
+          </a:p>
+        </p:txBody>
+      </p:sp>
+      <p:sp>
+        <p:nvSpPr>
+          <p:cNvPr id="12" name="Rectangle 11"/>
+          <p:cNvSpPr/>
+          <p:nvPr/>
+        </p:nvSpPr>
+        <p:spPr>
+          <a:xfrm>
+            <a:off x="2463800" y="9969500"/>
+            <a:ext cx="1778000" cy="6350"/>
+          </a:xfrm>
+          <a:prstGeom prst="rect">
+            <a:avLst/>
+          </a:prstGeom>
+          <a:solidFill>
+            <a:srgbClr val="C4C9CE">
+              <a:alpha val="40000"/>
+            </a:srgbClr>
+          </a:solidFill>
+          <a:ln>
+            <a:noFill/>
+          </a:ln>
+          <a:effectLst/>
+        </p:spPr>
+        <p:style>
+          <a:lnRef idx="1">
+            <a:schemeClr val="accent1"/>
+          </a:lnRef>
+          <a:fillRef idx="3">
+            <a:schemeClr val="accent1"/>
+          </a:fillRef>
+          <a:effectRef idx="2">
+            <a:schemeClr val="accent1"/>
+          </a:effectRef>
+          <a:fontRef idx="minor">
+            <a:schemeClr val="lt1"/>
+          </a:fontRef>
+        </p:style>
+        <p:txBody>
+          <a:bodyPr rtlCol="0" anchor="ctr"/>
+          <a:lstStyle/>
+          <a:p>
+            <a:pPr algn="ctr"/>
+          </a:p>
+        </p:txBody>
+      </p:sp>
+      <p:sp>
+        <p:nvSpPr>
+          <p:cNvPr id="13" name="TextBox 12"/>
           <p:cNvSpPr txBox="1"/>
           <p:nvPr/>
         </p:nvSpPr>
         <p:spPr>
           <a:xfrm>
-            <a:off x="533400" y="11671300"/>
-            <a:ext cx="3175000" cy="190500"/>
+            <a:off x="2463800" y="10109200"/>
+            <a:ext cx="1778000" cy="190500"/>
           </a:xfrm>
           <a:prstGeom prst="rect">
             <a:avLst/>
@@ -14843,7 +14879,7 @@
               </a:spcBef>
             </a:pPr>
             <a:r>
-              <a:rPr sz="1000" lang="ru-RU" spc="250">
+              <a:rPr sz="1000" lang="ru-RU" spc="200">
                 <a:solidFill>
                   <a:srgbClr val="8C939A"/>
                 </a:solidFill>
@@ -14851,6 +14887,222 @@
                 <a:ea typeface="Montserrat Medium"/>
                 <a:cs typeface="Montserrat Medium"/>
               </a:rPr>
+              <a:t>ДИСКИ</a:t>
+            </a:r>
+          </a:p>
+        </p:txBody>
+      </p:sp>
+      <p:sp>
+        <p:nvSpPr>
+          <p:cNvPr id="14" name="TextBox 13"/>
+          <p:cNvSpPr txBox="1"/>
+          <p:nvPr/>
+        </p:nvSpPr>
+        <p:spPr>
+          <a:xfrm>
+            <a:off x="2463800" y="10350500"/>
+            <a:ext cx="1866900" cy="508000"/>
+          </a:xfrm>
+          <a:prstGeom prst="rect">
+            <a:avLst/>
+          </a:prstGeom>
+          <a:noFill/>
+        </p:spPr>
+        <p:txBody>
+          <a:bodyPr wrap="square" lIns="0" rIns="0" tIns="0" bIns="0" anchor="t">
+            <a:noAutofit/>
+          </a:bodyPr>
+          <a:lstStyle/>
+          <a:p>
+            <a:pPr algn="l">
+              <a:lnSpc>
+                <a:spcPts val="2000"/>
+              </a:lnSpc>
+              <a:spcBef>
+                <a:spcPts val="0"/>
+              </a:spcBef>
+            </a:pPr>
+            <a:r>
+              <a:rPr sz="1600" lang="ru-RU">
+                <a:solidFill>
+                  <a:srgbClr val="FFFFFF"/>
+                </a:solidFill>
+                <a:latin typeface="Montserrat Light"/>
+                <a:ea typeface="Montserrat Light"/>
+                <a:cs typeface="Montserrat Light"/>
+              </a:rPr>
+              <a:t>Карбон-керамика</a:t>
+            </a:r>
+          </a:p>
+        </p:txBody>
+      </p:sp>
+      <p:sp>
+        <p:nvSpPr>
+          <p:cNvPr id="15" name="Rectangle 14"/>
+          <p:cNvSpPr/>
+          <p:nvPr/>
+        </p:nvSpPr>
+        <p:spPr>
+          <a:xfrm>
+            <a:off x="4394200" y="9969500"/>
+            <a:ext cx="1778000" cy="6350"/>
+          </a:xfrm>
+          <a:prstGeom prst="rect">
+            <a:avLst/>
+          </a:prstGeom>
+          <a:solidFill>
+            <a:srgbClr val="C4C9CE">
+              <a:alpha val="40000"/>
+            </a:srgbClr>
+          </a:solidFill>
+          <a:ln>
+            <a:noFill/>
+          </a:ln>
+          <a:effectLst/>
+        </p:spPr>
+        <p:style>
+          <a:lnRef idx="1">
+            <a:schemeClr val="accent1"/>
+          </a:lnRef>
+          <a:fillRef idx="3">
+            <a:schemeClr val="accent1"/>
+          </a:fillRef>
+          <a:effectRef idx="2">
+            <a:schemeClr val="accent1"/>
+          </a:effectRef>
+          <a:fontRef idx="minor">
+            <a:schemeClr val="lt1"/>
+          </a:fontRef>
+        </p:style>
+        <p:txBody>
+          <a:bodyPr rtlCol="0" anchor="ctr"/>
+          <a:lstStyle/>
+          <a:p>
+            <a:pPr algn="ctr"/>
+          </a:p>
+        </p:txBody>
+      </p:sp>
+      <p:sp>
+        <p:nvSpPr>
+          <p:cNvPr id="16" name="TextBox 15"/>
+          <p:cNvSpPr txBox="1"/>
+          <p:nvPr/>
+        </p:nvSpPr>
+        <p:spPr>
+          <a:xfrm>
+            <a:off x="4394200" y="10109200"/>
+            <a:ext cx="1778000" cy="190500"/>
+          </a:xfrm>
+          <a:prstGeom prst="rect">
+            <a:avLst/>
+          </a:prstGeom>
+          <a:noFill/>
+        </p:spPr>
+        <p:txBody>
+          <a:bodyPr wrap="square" lIns="0" rIns="0" tIns="0" bIns="0" anchor="t">
+            <a:noAutofit/>
+          </a:bodyPr>
+          <a:lstStyle/>
+          <a:p>
+            <a:pPr algn="l">
+              <a:spcBef>
+                <a:spcPts val="0"/>
+              </a:spcBef>
+            </a:pPr>
+            <a:r>
+              <a:rPr sz="1000" lang="ru-RU" spc="200">
+                <a:solidFill>
+                  <a:srgbClr val="8C939A"/>
+                </a:solidFill>
+                <a:latin typeface="Montserrat Medium"/>
+                <a:ea typeface="Montserrat Medium"/>
+                <a:cs typeface="Montserrat Medium"/>
+              </a:rPr>
+              <a:t>КОМПОНЕНТЫ</a:t>
+            </a:r>
+          </a:p>
+        </p:txBody>
+      </p:sp>
+      <p:sp>
+        <p:nvSpPr>
+          <p:cNvPr id="17" name="TextBox 16"/>
+          <p:cNvSpPr txBox="1"/>
+          <p:nvPr/>
+        </p:nvSpPr>
+        <p:spPr>
+          <a:xfrm>
+            <a:off x="4394200" y="10350500"/>
+            <a:ext cx="1866900" cy="508000"/>
+          </a:xfrm>
+          <a:prstGeom prst="rect">
+            <a:avLst/>
+          </a:prstGeom>
+          <a:noFill/>
+        </p:spPr>
+        <p:txBody>
+          <a:bodyPr wrap="square" lIns="0" rIns="0" tIns="0" bIns="0" anchor="t">
+            <a:noAutofit/>
+          </a:bodyPr>
+          <a:lstStyle/>
+          <a:p>
+            <a:pPr algn="l">
+              <a:lnSpc>
+                <a:spcPts val="2000"/>
+              </a:lnSpc>
+              <a:spcBef>
+                <a:spcPts val="0"/>
+              </a:spcBef>
+            </a:pPr>
+            <a:r>
+              <a:rPr sz="1600" lang="ru-RU">
+                <a:solidFill>
+                  <a:srgbClr val="FFFFFF"/>
+                </a:solidFill>
+                <a:latin typeface="Montserrat Light"/>
+                <a:ea typeface="Montserrat Light"/>
+                <a:cs typeface="Montserrat Light"/>
+              </a:rPr>
+              <a:t>Оригинальные</a:t>
+            </a:r>
+          </a:p>
+        </p:txBody>
+      </p:sp>
+      <p:sp>
+        <p:nvSpPr>
+          <p:cNvPr id="18" name="TextBox 17"/>
+          <p:cNvSpPr txBox="1"/>
+          <p:nvPr/>
+        </p:nvSpPr>
+        <p:spPr>
+          <a:xfrm>
+            <a:off x="533400" y="11671300"/>
+            <a:ext cx="3175000" cy="190500"/>
+          </a:xfrm>
+          <a:prstGeom prst="rect">
+            <a:avLst/>
+          </a:prstGeom>
+          <a:noFill/>
+        </p:spPr>
+        <p:txBody>
+          <a:bodyPr wrap="square" lIns="0" rIns="0" tIns="0" bIns="0" anchor="t">
+            <a:noAutofit/>
+          </a:bodyPr>
+          <a:lstStyle/>
+          <a:p>
+            <a:pPr algn="l">
+              <a:spcBef>
+                <a:spcPts val="0"/>
+              </a:spcBef>
+            </a:pPr>
+            <a:r>
+              <a:rPr sz="1000" lang="ru-RU" spc="250">
+                <a:solidFill>
+                  <a:srgbClr val="8C939A"/>
+                </a:solidFill>
+                <a:latin typeface="Montserrat Medium"/>
+                <a:ea typeface="Montserrat Medium"/>
+                <a:cs typeface="Montserrat Medium"/>
+              </a:rPr>
               <a:t>GRANDRIMS</a:t>
             </a:r>
           </a:p>
@@ -14858,7 +15110,7 @@
       </p:sp>
       <p:sp>
         <p:nvSpPr>
-          <p:cNvPr id="17" name="Rectangle 16"/>
+          <p:cNvPr id="19" name="Rectangle 18"/>
           <p:cNvSpPr/>
           <p:nvPr/>
         </p:nvSpPr>
@@ -14902,7 +15154,7 @@
       </p:sp>
       <p:sp>
         <p:nvSpPr>
-          <p:cNvPr id="18" name="TextBox 17"/>
+          <p:cNvPr id="20" name="TextBox 19"/>
           <p:cNvSpPr txBox="1"/>
           <p:nvPr/>
         </p:nvSpPr>

</xml_diff>

<commit_message>
GRANDRIMS x Mercedes-Benz deck: new wheel and AMG E-Class photos (slides 5, 6, 7)
Co-Authored-By: Claude Sonnet 5.5 <noreply@anthropic.com>
Claude-Session: https://claude.ai/code/session_01Gh1izjdNn5w7VE18yf9oT6
</commit_message>
<xml_diff>
--- a/grandrims-mb/GRANDRIMS_Mercedes-Benz_KP.pptx
+++ b/grandrims-mb/GRANDRIMS_Mercedes-Benz_KP.pptx
@@ -1074,7 +1074,7 @@
           <a:lstStyle/>
           <a:p>
             <a:r>
-              <a:t>Дизайн дисков. 01 — предметное фото комплекта GRANDRIMS; 02–04 — фрагменты фото автомобилей (S-Class, Maybach GLS, GLS).</a:t>
+              <a:t>Дизайн дисков. 01 и 02 — предметные фото комплектов; 03–04 — фрагменты фото автомобилей (S-Class, GLS).</a:t>
             </a:r>
           </a:p>
         </p:txBody>
@@ -1214,7 +1214,7 @@
           <a:lstStyle/>
           <a:p>
             <a:r>
-              <a:t>AMG / Performance. Фото: красный W124 с пятилучевыми дисками. Для более «AMG»-подачи можно заменить на фото с AMG-автомобилем.</a:t>
+              <a:t>AMG / Performance. Фото: серый Mercedes-AMG E-Class, вид сзади, ночь. Водяной знак с исходного фото убран кадрированием.</a:t>
             </a:r>
           </a:p>
         </p:txBody>
@@ -12072,7 +12072,7 @@
         </p:nvSpPr>
         <p:spPr>
           <a:xfrm>
-            <a:off x="533400" y="7588250"/>
+            <a:off x="533400" y="7213600"/>
             <a:ext cx="419100" cy="279400"/>
           </a:xfrm>
           <a:prstGeom prst="rect">
@@ -12118,7 +12118,7 @@
         </p:nvSpPr>
         <p:spPr>
           <a:xfrm>
-            <a:off x="635000" y="7645400"/>
+            <a:off x="635000" y="7270750"/>
             <a:ext cx="508000" cy="190500"/>
           </a:xfrm>
           <a:prstGeom prst="rect">
@@ -12159,7 +12159,7 @@
         </p:nvSpPr>
         <p:spPr>
           <a:xfrm>
-            <a:off x="2514600" y="7588250"/>
+            <a:off x="2514600" y="7213600"/>
             <a:ext cx="419100" cy="279400"/>
           </a:xfrm>
           <a:prstGeom prst="rect">
@@ -12205,7 +12205,7 @@
         </p:nvSpPr>
         <p:spPr>
           <a:xfrm>
-            <a:off x="2616200" y="7645400"/>
+            <a:off x="2616200" y="7270750"/>
             <a:ext cx="508000" cy="190500"/>
           </a:xfrm>
           <a:prstGeom prst="rect">
@@ -12246,7 +12246,7 @@
         </p:nvSpPr>
         <p:spPr>
           <a:xfrm>
-            <a:off x="4495800" y="7588250"/>
+            <a:off x="4495800" y="7213600"/>
             <a:ext cx="419100" cy="279400"/>
           </a:xfrm>
           <a:prstGeom prst="rect">
@@ -12292,7 +12292,7 @@
         </p:nvSpPr>
         <p:spPr>
           <a:xfrm>
-            <a:off x="4597400" y="7645400"/>
+            <a:off x="4597400" y="7270750"/>
             <a:ext cx="508000" cy="190500"/>
           </a:xfrm>
           <a:prstGeom prst="rect">
@@ -12333,7 +12333,7 @@
         </p:nvSpPr>
         <p:spPr>
           <a:xfrm>
-            <a:off x="533400" y="9258300"/>
+            <a:off x="533400" y="8915400"/>
             <a:ext cx="5791200" cy="6350"/>
           </a:xfrm>
           <a:prstGeom prst="rect">
@@ -12379,7 +12379,7 @@
         </p:nvSpPr>
         <p:spPr>
           <a:xfrm>
-            <a:off x="533400" y="9372600"/>
+            <a:off x="533400" y="9029700"/>
             <a:ext cx="571500" cy="254000"/>
           </a:xfrm>
           <a:prstGeom prst="rect">
@@ -12420,7 +12420,7 @@
         </p:nvSpPr>
         <p:spPr>
           <a:xfrm>
-            <a:off x="1206500" y="9321800"/>
+            <a:off x="1206500" y="8978900"/>
             <a:ext cx="4445000" cy="279400"/>
           </a:xfrm>
           <a:prstGeom prst="rect">
@@ -12448,7 +12448,7 @@
                 <a:ea typeface="Montserrat Medium"/>
                 <a:cs typeface="Montserrat Medium"/>
               </a:rPr>
-              <a:t>Кованый комплект</a:t>
+              <a:t>Строгий Mercedes-Benz</a:t>
             </a:r>
           </a:p>
         </p:txBody>
@@ -12461,7 +12461,7 @@
         </p:nvSpPr>
         <p:spPr>
           <a:xfrm>
-            <a:off x="1206500" y="9550400"/>
+            <a:off x="1206500" y="9207500"/>
             <a:ext cx="4953000" cy="215900"/>
           </a:xfrm>
           <a:prstGeom prst="rect">
@@ -12489,7 +12489,7 @@
                 <a:ea typeface="Montserrat Light"/>
                 <a:cs typeface="Montserrat Light"/>
               </a:rPr>
-              <a:t>чёрный лак, контрастная кромка</a:t>
+              <a:t>чёрный лак и полированная кромка спиц</a:t>
             </a:r>
           </a:p>
         </p:txBody>
@@ -12502,7 +12502,7 @@
         </p:nvSpPr>
         <p:spPr>
           <a:xfrm>
-            <a:off x="533400" y="9817100"/>
+            <a:off x="533400" y="9474200"/>
             <a:ext cx="5791200" cy="6350"/>
           </a:xfrm>
           <a:prstGeom prst="rect">
@@ -12548,7 +12548,7 @@
         </p:nvSpPr>
         <p:spPr>
           <a:xfrm>
-            <a:off x="533400" y="9931400"/>
+            <a:off x="533400" y="9588500"/>
             <a:ext cx="571500" cy="254000"/>
           </a:xfrm>
           <a:prstGeom prst="rect">
@@ -12589,7 +12589,7 @@
         </p:nvSpPr>
         <p:spPr>
           <a:xfrm>
-            <a:off x="1206500" y="9880600"/>
+            <a:off x="1206500" y="9537700"/>
             <a:ext cx="4445000" cy="279400"/>
           </a:xfrm>
           <a:prstGeom prst="rect">
@@ -12617,7 +12617,7 @@
                 <a:ea typeface="Montserrat Medium"/>
                 <a:cs typeface="Montserrat Medium"/>
               </a:rPr>
-              <a:t>Многоспицевый</a:t>
+              <a:t>Maybach-style</a:t>
             </a:r>
           </a:p>
         </p:txBody>
@@ -12630,7 +12630,7 @@
         </p:nvSpPr>
         <p:spPr>
           <a:xfrm>
-            <a:off x="1206500" y="10109200"/>
+            <a:off x="1206500" y="9766300"/>
             <a:ext cx="4953000" cy="215900"/>
           </a:xfrm>
           <a:prstGeom prst="rect">
@@ -12658,7 +12658,7 @@
                 <a:ea typeface="Montserrat Light"/>
                 <a:cs typeface="Montserrat Light"/>
               </a:rPr>
-              <a:t>турбинный рисунок</a:t>
+              <a:t>полированные поверхности и объём</a:t>
             </a:r>
           </a:p>
         </p:txBody>
@@ -12671,7 +12671,7 @@
         </p:nvSpPr>
         <p:spPr>
           <a:xfrm>
-            <a:off x="533400" y="10375900"/>
+            <a:off x="533400" y="10033000"/>
             <a:ext cx="5791200" cy="6350"/>
           </a:xfrm>
           <a:prstGeom prst="rect">
@@ -12717,7 +12717,7 @@
         </p:nvSpPr>
         <p:spPr>
           <a:xfrm>
-            <a:off x="533400" y="10490200"/>
+            <a:off x="533400" y="10147300"/>
             <a:ext cx="571500" cy="254000"/>
           </a:xfrm>
           <a:prstGeom prst="rect">
@@ -12758,7 +12758,7 @@
         </p:nvSpPr>
         <p:spPr>
           <a:xfrm>
-            <a:off x="1206500" y="10439400"/>
+            <a:off x="1206500" y="10096500"/>
             <a:ext cx="4445000" cy="279400"/>
           </a:xfrm>
           <a:prstGeom prst="rect">
@@ -12786,7 +12786,7 @@
                 <a:ea typeface="Montserrat Medium"/>
                 <a:cs typeface="Montserrat Medium"/>
               </a:rPr>
-              <a:t>Maybach-style</a:t>
+              <a:t>Многоспицевый</a:t>
             </a:r>
           </a:p>
         </p:txBody>
@@ -12799,7 +12799,7 @@
         </p:nvSpPr>
         <p:spPr>
           <a:xfrm>
-            <a:off x="1206500" y="10668000"/>
+            <a:off x="1206500" y="10325100"/>
             <a:ext cx="4953000" cy="215900"/>
           </a:xfrm>
           <a:prstGeom prst="rect">
@@ -12827,7 +12827,7 @@
                 <a:ea typeface="Montserrat Light"/>
                 <a:cs typeface="Montserrat Light"/>
               </a:rPr>
-              <a:t>хром и объём</a:t>
+              <a:t>турбинный рисунок</a:t>
             </a:r>
           </a:p>
         </p:txBody>
@@ -12840,7 +12840,7 @@
         </p:nvSpPr>
         <p:spPr>
           <a:xfrm>
-            <a:off x="533400" y="10934700"/>
+            <a:off x="533400" y="10591800"/>
             <a:ext cx="5791200" cy="6350"/>
           </a:xfrm>
           <a:prstGeom prst="rect">
@@ -12886,7 +12886,7 @@
         </p:nvSpPr>
         <p:spPr>
           <a:xfrm>
-            <a:off x="533400" y="11049000"/>
+            <a:off x="533400" y="10706100"/>
             <a:ext cx="571500" cy="254000"/>
           </a:xfrm>
           <a:prstGeom prst="rect">
@@ -12927,7 +12927,7 @@
         </p:nvSpPr>
         <p:spPr>
           <a:xfrm>
-            <a:off x="1206500" y="10998200"/>
+            <a:off x="1206500" y="10655300"/>
             <a:ext cx="4445000" cy="279400"/>
           </a:xfrm>
           <a:prstGeom prst="rect">
@@ -12968,7 +12968,7 @@
         </p:nvSpPr>
         <p:spPr>
           <a:xfrm>
-            <a:off x="1206500" y="11226800"/>
+            <a:off x="1206500" y="10883900"/>
             <a:ext cx="4953000" cy="215900"/>
           </a:xfrm>
           <a:prstGeom prst="rect">
@@ -12996,7 +12996,7 @@
                 <a:ea typeface="Montserrat Light"/>
                 <a:cs typeface="Montserrat Light"/>
               </a:rPr>
-              <a:t>чёрный лак, полированная кромка</a:t>
+              <a:t>монолитный чёрный диск</a:t>
             </a:r>
           </a:p>
         </p:txBody>
@@ -13692,7 +13692,7 @@
         </p:nvSpPr>
         <p:spPr>
           <a:xfrm>
-            <a:off x="533400" y="8712200"/>
+            <a:off x="533400" y="1143000"/>
             <a:ext cx="5842000" cy="2095500"/>
           </a:xfrm>
           <a:prstGeom prst="rect">
@@ -13778,8 +13778,8 @@
         </p:nvSpPr>
         <p:spPr>
           <a:xfrm>
-            <a:off x="533400" y="10896600"/>
-            <a:ext cx="4445000" cy="444500"/>
+            <a:off x="533400" y="3429000"/>
+            <a:ext cx="4445000" cy="698500"/>
           </a:xfrm>
           <a:prstGeom prst="rect">
             <a:avLst/>
@@ -13794,14 +13794,14 @@
           <a:p>
             <a:pPr algn="l">
               <a:lnSpc>
-                <a:spcPts val="1900"/>
+                <a:spcPts val="2200"/>
               </a:lnSpc>
               <a:spcBef>
                 <a:spcPts val="0"/>
               </a:spcBef>
             </a:pPr>
             <a:r>
-              <a:rPr sz="1350" lang="ru-RU">
+              <a:rPr sz="1500" lang="ru-RU">
                 <a:solidFill>
                   <a:srgbClr val="C4C9CE"/>
                 </a:solidFill>

</xml_diff>

<commit_message>
GRANDRIMS x Mercedes-Benz deck: product wheel photos on slides 5 and 8
Co-Authored-By: Claude Sonnet 5.5 <noreply@anthropic.com>
Claude-Session: https://claude.ai/code/session_01Gh1izjdNn5w7VE18yf9oT6
</commit_message>
<xml_diff>
--- a/grandrims-mb/GRANDRIMS_Mercedes-Benz_KP.pptx
+++ b/grandrims-mb/GRANDRIMS_Mercedes-Benz_KP.pptx
@@ -1074,7 +1074,7 @@
           <a:lstStyle/>
           <a:p>
             <a:r>
-              <a:t>Дизайн дисков. 01 и 02 — предметные фото комплектов; 03–04 — фрагменты фото автомобилей (S-Class, GLS).</a:t>
+              <a:t>Дизайн дисков. Все четыре кадра — предметные фото комплектов: строгий Mercedes-Benz, Maybach-style, AMG-style, G-Class.</a:t>
             </a:r>
           </a:p>
         </p:txBody>
@@ -12786,7 +12786,7 @@
                 <a:ea typeface="Montserrat Medium"/>
                 <a:cs typeface="Montserrat Medium"/>
               </a:rPr>
-              <a:t>Многоспицевый</a:t>
+              <a:t>AMG-style</a:t>
             </a:r>
           </a:p>
         </p:txBody>
@@ -12827,7 +12827,7 @@
                 <a:ea typeface="Montserrat Light"/>
                 <a:cs typeface="Montserrat Light"/>
               </a:rPr>
-              <a:t>турбинный рисунок</a:t>
+              <a:t>многоспицевый рисунок, матовый графит</a:t>
             </a:r>
           </a:p>
         </p:txBody>
@@ -12955,7 +12955,7 @@
                 <a:ea typeface="Montserrat Medium"/>
                 <a:cs typeface="Montserrat Medium"/>
               </a:rPr>
-              <a:t>Массивный моноблок</a:t>
+              <a:t>G-Class</a:t>
             </a:r>
           </a:p>
         </p:txBody>
@@ -12996,7 +12996,7 @@
                 <a:ea typeface="Montserrat Light"/>
                 <a:cs typeface="Montserrat Light"/>
               </a:rPr>
-              <a:t>монолитный чёрный диск</a:t>
+              <a:t>массивный моноблок, матовый чёрный</a:t>
             </a:r>
           </a:p>
         </p:txBody>
@@ -14152,7 +14152,7 @@
         <p:spPr>
           <a:xfrm>
             <a:off x="533400" y="9842500"/>
-            <a:ext cx="4572000" cy="635000"/>
+            <a:ext cx="3556000" cy="1079500"/>
           </a:xfrm>
           <a:prstGeom prst="rect">
             <a:avLst/>

</xml_diff>

<commit_message>
GRANDRIMS x Mercedes-Benz deck: official logo on every slide, wheel product photos shown whole
Co-Authored-By: Claude Sonnet 5.5 <noreply@anthropic.com>
Claude-Session: https://claude.ai/code/session_01Gh1izjdNn5w7VE18yf9oT6
</commit_message>
<xml_diff>
--- a/grandrims-mb/GRANDRIMS_Mercedes-Benz_KP.pptx
+++ b/grandrims-mb/GRANDRIMS_Mercedes-Benz_KP.pptx
@@ -934,7 +934,7 @@
           <a:lstStyle/>
           <a:p>
             <a:r>
-              <a:t>Кованые диски. Детали колёс — кадрированные фрагменты фото GLS и S-Class. Если пришлёт предметные фото дисков GRANDRIMS — заменить этими кадрами.</a:t>
+              <a:t>Кованые диски. Кадр — предметное фото комплекта целиком, без кадрирования.</a:t>
             </a:r>
           </a:p>
         </p:txBody>
@@ -1144,7 +1144,7 @@
           <a:lstStyle/>
           <a:p>
             <a:r>
-              <a:t>Maybach / luxury. Фото: белый Maybach GLS с полированными дисками; круглая вставка — фрагмент колеса.</a:t>
+              <a:t>Maybach / luxury. Фото: белый Maybach GLS с полированными дисками; справа — предметное фото комплекта.</a:t>
             </a:r>
           </a:p>
         </p:txBody>
@@ -4386,7 +4386,7 @@
       </p:pic>
       <p:pic>
         <p:nvPicPr>
-          <p:cNvPr id="3" name="GRANDRIMS logo" descr="logo.png"/>
+          <p:cNvPr id="3" name="GRANDRIMS logo" descr="logo_dark.png"/>
           <p:cNvPicPr>
             <a:picLocks noChangeAspect="1"/>
           </p:cNvPicPr>
@@ -4400,8 +4400,8 @@
         </p:blipFill>
         <p:spPr>
           <a:xfrm>
-            <a:off x="533400" y="609600"/>
-            <a:ext cx="1498600" cy="347501"/>
+            <a:off x="533400" y="533400"/>
+            <a:ext cx="1778000" cy="575049"/>
           </a:xfrm>
           <a:prstGeom prst="rect">
             <a:avLst/>
@@ -5162,16 +5162,40 @@
           </a:p>
         </p:txBody>
       </p:sp>
-      <p:sp>
-        <p:nvSpPr>
-          <p:cNvPr id="12" name="TextBox 11"/>
+      <p:pic>
+        <p:nvPicPr>
+          <p:cNvPr id="12" name="GRANDRIMS logo" descr="logo_dark.png"/>
+          <p:cNvPicPr>
+            <a:picLocks noChangeAspect="1"/>
+          </p:cNvPicPr>
+          <p:nvPr/>
+        </p:nvPicPr>
+        <p:blipFill>
+          <a:blip r:embed="rId4"/>
+          <a:stretch>
+            <a:fillRect/>
+          </a:stretch>
+        </p:blipFill>
+        <p:spPr>
+          <a:xfrm>
+            <a:off x="4965700" y="482600"/>
+            <a:ext cx="1358900" cy="439502"/>
+          </a:xfrm>
+          <a:prstGeom prst="rect">
+            <a:avLst/>
+          </a:prstGeom>
+        </p:spPr>
+      </p:pic>
+      <p:sp>
+        <p:nvSpPr>
+          <p:cNvPr id="13" name="TextBox 12"/>
           <p:cNvSpPr txBox="1"/>
           <p:nvPr/>
         </p:nvSpPr>
         <p:spPr>
           <a:xfrm>
             <a:off x="533400" y="11671300"/>
-            <a:ext cx="3175000" cy="190500"/>
+            <a:ext cx="3556000" cy="190500"/>
           </a:xfrm>
           <a:prstGeom prst="rect">
             <a:avLst/>
@@ -5198,14 +5222,14 @@
                 <a:ea typeface="Montserrat Medium"/>
                 <a:cs typeface="Montserrat Medium"/>
               </a:rPr>
-              <a:t>GRANDRIMS</a:t>
-            </a:r>
-          </a:p>
-        </p:txBody>
-      </p:sp>
-      <p:sp>
-        <p:nvSpPr>
-          <p:cNvPr id="13" name="Rectangle 12"/>
+              <a:t>КОММЕРЧЕСКОЕ ПРЕДЛОЖЕНИЕ</a:t>
+            </a:r>
+          </a:p>
+        </p:txBody>
+      </p:sp>
+      <p:sp>
+        <p:nvSpPr>
+          <p:cNvPr id="14" name="Rectangle 13"/>
           <p:cNvSpPr/>
           <p:nvPr/>
         </p:nvSpPr>
@@ -5249,7 +5273,7 @@
       </p:sp>
       <p:sp>
         <p:nvSpPr>
-          <p:cNvPr id="14" name="TextBox 13"/>
+          <p:cNvPr id="15" name="TextBox 14"/>
           <p:cNvSpPr txBox="1"/>
           <p:nvPr/>
         </p:nvSpPr>
@@ -6423,16 +6447,40 @@
           </a:p>
         </p:txBody>
       </p:sp>
-      <p:sp>
-        <p:nvSpPr>
-          <p:cNvPr id="27" name="TextBox 26"/>
+      <p:pic>
+        <p:nvPicPr>
+          <p:cNvPr id="27" name="GRANDRIMS logo" descr="logo_dark.png"/>
+          <p:cNvPicPr>
+            <a:picLocks noChangeAspect="1"/>
+          </p:cNvPicPr>
+          <p:nvPr/>
+        </p:nvPicPr>
+        <p:blipFill>
+          <a:blip r:embed="rId3"/>
+          <a:stretch>
+            <a:fillRect/>
+          </a:stretch>
+        </p:blipFill>
+        <p:spPr>
+          <a:xfrm>
+            <a:off x="4965700" y="482600"/>
+            <a:ext cx="1358900" cy="439502"/>
+          </a:xfrm>
+          <a:prstGeom prst="rect">
+            <a:avLst/>
+          </a:prstGeom>
+        </p:spPr>
+      </p:pic>
+      <p:sp>
+        <p:nvSpPr>
+          <p:cNvPr id="28" name="TextBox 27"/>
           <p:cNvSpPr txBox="1"/>
           <p:nvPr/>
         </p:nvSpPr>
         <p:spPr>
           <a:xfrm>
             <a:off x="533400" y="11671300"/>
-            <a:ext cx="3175000" cy="190500"/>
+            <a:ext cx="3556000" cy="190500"/>
           </a:xfrm>
           <a:prstGeom prst="rect">
             <a:avLst/>
@@ -6459,14 +6507,14 @@
                 <a:ea typeface="Montserrat Medium"/>
                 <a:cs typeface="Montserrat Medium"/>
               </a:rPr>
-              <a:t>GRANDRIMS</a:t>
-            </a:r>
-          </a:p>
-        </p:txBody>
-      </p:sp>
-      <p:sp>
-        <p:nvSpPr>
-          <p:cNvPr id="28" name="Rectangle 27"/>
+              <a:t>КОММЕРЧЕСКОЕ ПРЕДЛОЖЕНИЕ</a:t>
+            </a:r>
+          </a:p>
+        </p:txBody>
+      </p:sp>
+      <p:sp>
+        <p:nvSpPr>
+          <p:cNvPr id="29" name="Rectangle 28"/>
           <p:cNvSpPr/>
           <p:nvPr/>
         </p:nvSpPr>
@@ -6510,7 +6558,7 @@
       </p:sp>
       <p:sp>
         <p:nvSpPr>
-          <p:cNvPr id="29" name="TextBox 28"/>
+          <p:cNvPr id="30" name="TextBox 29"/>
           <p:cNvSpPr txBox="1"/>
           <p:nvPr/>
         </p:nvSpPr>
@@ -8875,16 +8923,40 @@
           </a:p>
         </p:txBody>
       </p:sp>
-      <p:sp>
-        <p:nvSpPr>
-          <p:cNvPr id="56" name="TextBox 55"/>
+      <p:pic>
+        <p:nvPicPr>
+          <p:cNvPr id="56" name="GRANDRIMS logo" descr="logo_light.png"/>
+          <p:cNvPicPr>
+            <a:picLocks noChangeAspect="1"/>
+          </p:cNvPicPr>
+          <p:nvPr/>
+        </p:nvPicPr>
+        <p:blipFill>
+          <a:blip r:embed="rId3"/>
+          <a:stretch>
+            <a:fillRect/>
+          </a:stretch>
+        </p:blipFill>
+        <p:spPr>
+          <a:xfrm>
+            <a:off x="4965700" y="482600"/>
+            <a:ext cx="1358900" cy="439502"/>
+          </a:xfrm>
+          <a:prstGeom prst="rect">
+            <a:avLst/>
+          </a:prstGeom>
+        </p:spPr>
+      </p:pic>
+      <p:sp>
+        <p:nvSpPr>
+          <p:cNvPr id="57" name="TextBox 56"/>
           <p:cNvSpPr txBox="1"/>
           <p:nvPr/>
         </p:nvSpPr>
         <p:spPr>
           <a:xfrm>
             <a:off x="533400" y="11671300"/>
-            <a:ext cx="3175000" cy="190500"/>
+            <a:ext cx="3556000" cy="190500"/>
           </a:xfrm>
           <a:prstGeom prst="rect">
             <a:avLst/>
@@ -8911,14 +8983,14 @@
                 <a:ea typeface="Montserrat Medium"/>
                 <a:cs typeface="Montserrat Medium"/>
               </a:rPr>
-              <a:t>GRANDRIMS</a:t>
-            </a:r>
-          </a:p>
-        </p:txBody>
-      </p:sp>
-      <p:sp>
-        <p:nvSpPr>
-          <p:cNvPr id="57" name="Rectangle 56"/>
+              <a:t>КОММЕРЧЕСКОЕ ПРЕДЛОЖЕНИЕ</a:t>
+            </a:r>
+          </a:p>
+        </p:txBody>
+      </p:sp>
+      <p:sp>
+        <p:nvSpPr>
+          <p:cNvPr id="58" name="Rectangle 57"/>
           <p:cNvSpPr/>
           <p:nvPr/>
         </p:nvSpPr>
@@ -8962,7 +9034,7 @@
       </p:sp>
       <p:sp>
         <p:nvSpPr>
-          <p:cNvPr id="58" name="TextBox 57"/>
+          <p:cNvPr id="59" name="TextBox 58"/>
           <p:cNvSpPr txBox="1"/>
           <p:nvPr/>
         </p:nvSpPr>
@@ -9056,7 +9128,7 @@
       </p:pic>
       <p:pic>
         <p:nvPicPr>
-          <p:cNvPr id="3" name="GRANDRIMS logo" descr="logo.png"/>
+          <p:cNvPr id="3" name="GRANDRIMS logo" descr="logo_dark.png"/>
           <p:cNvPicPr>
             <a:picLocks noChangeAspect="1"/>
           </p:cNvPicPr>
@@ -9070,8 +9142,8 @@
         </p:blipFill>
         <p:spPr>
           <a:xfrm>
-            <a:off x="533400" y="609600"/>
-            <a:ext cx="1498600" cy="347501"/>
+            <a:off x="533400" y="533400"/>
+            <a:ext cx="1778000" cy="575049"/>
           </a:xfrm>
           <a:prstGeom prst="rect">
             <a:avLst/>
@@ -9757,16 +9829,40 @@
           </a:p>
         </p:txBody>
       </p:sp>
-      <p:sp>
-        <p:nvSpPr>
-          <p:cNvPr id="8" name="TextBox 7"/>
+      <p:pic>
+        <p:nvPicPr>
+          <p:cNvPr id="8" name="GRANDRIMS logo" descr="logo_light.png"/>
+          <p:cNvPicPr>
+            <a:picLocks noChangeAspect="1"/>
+          </p:cNvPicPr>
+          <p:nvPr/>
+        </p:nvPicPr>
+        <p:blipFill>
+          <a:blip r:embed="rId3"/>
+          <a:stretch>
+            <a:fillRect/>
+          </a:stretch>
+        </p:blipFill>
+        <p:spPr>
+          <a:xfrm>
+            <a:off x="4965700" y="482600"/>
+            <a:ext cx="1358900" cy="439502"/>
+          </a:xfrm>
+          <a:prstGeom prst="rect">
+            <a:avLst/>
+          </a:prstGeom>
+        </p:spPr>
+      </p:pic>
+      <p:sp>
+        <p:nvSpPr>
+          <p:cNvPr id="9" name="TextBox 8"/>
           <p:cNvSpPr txBox="1"/>
           <p:nvPr/>
         </p:nvSpPr>
         <p:spPr>
           <a:xfrm>
             <a:off x="533400" y="11671300"/>
-            <a:ext cx="3175000" cy="190500"/>
+            <a:ext cx="3556000" cy="190500"/>
           </a:xfrm>
           <a:prstGeom prst="rect">
             <a:avLst/>
@@ -9793,14 +9889,14 @@
                 <a:ea typeface="Montserrat Medium"/>
                 <a:cs typeface="Montserrat Medium"/>
               </a:rPr>
-              <a:t>GRANDRIMS</a:t>
-            </a:r>
-          </a:p>
-        </p:txBody>
-      </p:sp>
-      <p:sp>
-        <p:nvSpPr>
-          <p:cNvPr id="9" name="Rectangle 8"/>
+              <a:t>КОММЕРЧЕСКОЕ ПРЕДЛОЖЕНИЕ</a:t>
+            </a:r>
+          </a:p>
+        </p:txBody>
+      </p:sp>
+      <p:sp>
+        <p:nvSpPr>
+          <p:cNvPr id="10" name="Rectangle 9"/>
           <p:cNvSpPr/>
           <p:nvPr/>
         </p:nvSpPr>
@@ -9844,7 +9940,7 @@
       </p:sp>
       <p:sp>
         <p:nvSpPr>
-          <p:cNvPr id="10" name="TextBox 9"/>
+          <p:cNvPr id="11" name="TextBox 10"/>
           <p:cNvSpPr txBox="1"/>
           <p:nvPr/>
         </p:nvSpPr>
@@ -10326,16 +10422,40 @@
           </a:p>
         </p:txBody>
       </p:sp>
-      <p:sp>
-        <p:nvSpPr>
-          <p:cNvPr id="11" name="TextBox 10"/>
+      <p:pic>
+        <p:nvPicPr>
+          <p:cNvPr id="11" name="GRANDRIMS logo" descr="logo_dark.png"/>
+          <p:cNvPicPr>
+            <a:picLocks noChangeAspect="1"/>
+          </p:cNvPicPr>
+          <p:nvPr/>
+        </p:nvPicPr>
+        <p:blipFill>
+          <a:blip r:embed="rId3"/>
+          <a:stretch>
+            <a:fillRect/>
+          </a:stretch>
+        </p:blipFill>
+        <p:spPr>
+          <a:xfrm>
+            <a:off x="4965700" y="482600"/>
+            <a:ext cx="1358900" cy="439502"/>
+          </a:xfrm>
+          <a:prstGeom prst="rect">
+            <a:avLst/>
+          </a:prstGeom>
+        </p:spPr>
+      </p:pic>
+      <p:sp>
+        <p:nvSpPr>
+          <p:cNvPr id="12" name="TextBox 11"/>
           <p:cNvSpPr txBox="1"/>
           <p:nvPr/>
         </p:nvSpPr>
         <p:spPr>
           <a:xfrm>
-            <a:off x="533400" y="10795000"/>
-            <a:ext cx="2794000" cy="190500"/>
+            <a:off x="533400" y="11671300"/>
+            <a:ext cx="3556000" cy="190500"/>
           </a:xfrm>
           <a:prstGeom prst="rect">
             <a:avLst/>
@@ -10354,7 +10474,7 @@
               </a:spcBef>
             </a:pPr>
             <a:r>
-              <a:rPr sz="1000" lang="ru-RU" spc="200">
+              <a:rPr sz="1000" lang="ru-RU" spc="250">
                 <a:solidFill>
                   <a:srgbClr val="8C939A"/>
                 </a:solidFill>
@@ -10362,96 +10482,14 @@
                 <a:ea typeface="Montserrat Medium"/>
                 <a:cs typeface="Montserrat Medium"/>
               </a:rPr>
-              <a:t>GLS</a:t>
-            </a:r>
-          </a:p>
-        </p:txBody>
-      </p:sp>
-      <p:sp>
-        <p:nvSpPr>
-          <p:cNvPr id="12" name="TextBox 11"/>
-          <p:cNvSpPr txBox="1"/>
-          <p:nvPr/>
-        </p:nvSpPr>
-        <p:spPr>
-          <a:xfrm>
-            <a:off x="3530600" y="11239500"/>
-            <a:ext cx="2794000" cy="190500"/>
-          </a:xfrm>
-          <a:prstGeom prst="rect">
-            <a:avLst/>
-          </a:prstGeom>
-          <a:noFill/>
-        </p:spPr>
-        <p:txBody>
-          <a:bodyPr wrap="square" lIns="0" rIns="0" tIns="0" bIns="0" anchor="t">
-            <a:noAutofit/>
-          </a:bodyPr>
-          <a:lstStyle/>
-          <a:p>
-            <a:pPr algn="l">
-              <a:spcBef>
-                <a:spcPts val="0"/>
-              </a:spcBef>
-            </a:pPr>
-            <a:r>
-              <a:rPr sz="1000" lang="ru-RU" spc="200">
-                <a:solidFill>
-                  <a:srgbClr val="8C939A"/>
-                </a:solidFill>
-                <a:latin typeface="Montserrat Medium"/>
-                <a:ea typeface="Montserrat Medium"/>
-                <a:cs typeface="Montserrat Medium"/>
-              </a:rPr>
-              <a:t>S-CLASS</a:t>
-            </a:r>
-          </a:p>
-        </p:txBody>
-      </p:sp>
-      <p:sp>
-        <p:nvSpPr>
-          <p:cNvPr id="13" name="TextBox 12"/>
-          <p:cNvSpPr txBox="1"/>
-          <p:nvPr/>
-        </p:nvSpPr>
-        <p:spPr>
-          <a:xfrm>
-            <a:off x="533400" y="11671300"/>
-            <a:ext cx="3175000" cy="190500"/>
-          </a:xfrm>
-          <a:prstGeom prst="rect">
-            <a:avLst/>
-          </a:prstGeom>
-          <a:noFill/>
-        </p:spPr>
-        <p:txBody>
-          <a:bodyPr wrap="square" lIns="0" rIns="0" tIns="0" bIns="0" anchor="t">
-            <a:noAutofit/>
-          </a:bodyPr>
-          <a:lstStyle/>
-          <a:p>
-            <a:pPr algn="l">
-              <a:spcBef>
-                <a:spcPts val="0"/>
-              </a:spcBef>
-            </a:pPr>
-            <a:r>
-              <a:rPr sz="1000" lang="ru-RU" spc="250">
-                <a:solidFill>
-                  <a:srgbClr val="8C939A"/>
-                </a:solidFill>
-                <a:latin typeface="Montserrat Medium"/>
-                <a:ea typeface="Montserrat Medium"/>
-                <a:cs typeface="Montserrat Medium"/>
-              </a:rPr>
-              <a:t>GRANDRIMS</a:t>
-            </a:r>
-          </a:p>
-        </p:txBody>
-      </p:sp>
-      <p:sp>
-        <p:nvSpPr>
-          <p:cNvPr id="14" name="Rectangle 13"/>
+              <a:t>КОММЕРЧЕСКОЕ ПРЕДЛОЖЕНИЕ</a:t>
+            </a:r>
+          </a:p>
+        </p:txBody>
+      </p:sp>
+      <p:sp>
+        <p:nvSpPr>
+          <p:cNvPr id="13" name="Rectangle 12"/>
           <p:cNvSpPr/>
           <p:nvPr/>
         </p:nvSpPr>
@@ -10495,7 +10533,7 @@
       </p:sp>
       <p:sp>
         <p:nvSpPr>
-          <p:cNvPr id="15" name="TextBox 14"/>
+          <p:cNvPr id="14" name="TextBox 13"/>
           <p:cNvSpPr txBox="1"/>
           <p:nvPr/>
         </p:nvSpPr>
@@ -11648,16 +11686,40 @@
           </a:p>
         </p:txBody>
       </p:sp>
-      <p:sp>
-        <p:nvSpPr>
-          <p:cNvPr id="25" name="TextBox 24"/>
+      <p:pic>
+        <p:nvPicPr>
+          <p:cNvPr id="25" name="GRANDRIMS logo" descr="logo_dark.png"/>
+          <p:cNvPicPr>
+            <a:picLocks noChangeAspect="1"/>
+          </p:cNvPicPr>
+          <p:nvPr/>
+        </p:nvPicPr>
+        <p:blipFill>
+          <a:blip r:embed="rId3"/>
+          <a:stretch>
+            <a:fillRect/>
+          </a:stretch>
+        </p:blipFill>
+        <p:spPr>
+          <a:xfrm>
+            <a:off x="4965700" y="482600"/>
+            <a:ext cx="1358900" cy="439502"/>
+          </a:xfrm>
+          <a:prstGeom prst="rect">
+            <a:avLst/>
+          </a:prstGeom>
+        </p:spPr>
+      </p:pic>
+      <p:sp>
+        <p:nvSpPr>
+          <p:cNvPr id="26" name="TextBox 25"/>
           <p:cNvSpPr txBox="1"/>
           <p:nvPr/>
         </p:nvSpPr>
         <p:spPr>
           <a:xfrm>
             <a:off x="533400" y="11671300"/>
-            <a:ext cx="3175000" cy="190500"/>
+            <a:ext cx="3556000" cy="190500"/>
           </a:xfrm>
           <a:prstGeom prst="rect">
             <a:avLst/>
@@ -11684,14 +11746,14 @@
                 <a:ea typeface="Montserrat Medium"/>
                 <a:cs typeface="Montserrat Medium"/>
               </a:rPr>
-              <a:t>GRANDRIMS</a:t>
-            </a:r>
-          </a:p>
-        </p:txBody>
-      </p:sp>
-      <p:sp>
-        <p:nvSpPr>
-          <p:cNvPr id="26" name="Rectangle 25"/>
+              <a:t>КОММЕРЧЕСКОЕ ПРЕДЛОЖЕНИЕ</a:t>
+            </a:r>
+          </a:p>
+        </p:txBody>
+      </p:sp>
+      <p:sp>
+        <p:nvSpPr>
+          <p:cNvPr id="27" name="Rectangle 26"/>
           <p:cNvSpPr/>
           <p:nvPr/>
         </p:nvSpPr>
@@ -11735,7 +11797,7 @@
       </p:sp>
       <p:sp>
         <p:nvSpPr>
-          <p:cNvPr id="27" name="TextBox 26"/>
+          <p:cNvPr id="28" name="TextBox 27"/>
           <p:cNvSpPr txBox="1"/>
           <p:nvPr/>
         </p:nvSpPr>
@@ -12333,7 +12395,7 @@
         </p:nvSpPr>
         <p:spPr>
           <a:xfrm>
-            <a:off x="533400" y="8915400"/>
+            <a:off x="533400" y="8839200"/>
             <a:ext cx="5791200" cy="6350"/>
           </a:xfrm>
           <a:prstGeom prst="rect">
@@ -12379,7 +12441,7 @@
         </p:nvSpPr>
         <p:spPr>
           <a:xfrm>
-            <a:off x="533400" y="9029700"/>
+            <a:off x="533400" y="8953500"/>
             <a:ext cx="571500" cy="254000"/>
           </a:xfrm>
           <a:prstGeom prst="rect">
@@ -12420,7 +12482,7 @@
         </p:nvSpPr>
         <p:spPr>
           <a:xfrm>
-            <a:off x="1206500" y="8978900"/>
+            <a:off x="1206500" y="8902700"/>
             <a:ext cx="4445000" cy="279400"/>
           </a:xfrm>
           <a:prstGeom prst="rect">
@@ -12461,7 +12523,7 @@
         </p:nvSpPr>
         <p:spPr>
           <a:xfrm>
-            <a:off x="1206500" y="9207500"/>
+            <a:off x="1206500" y="9131300"/>
             <a:ext cx="4953000" cy="215900"/>
           </a:xfrm>
           <a:prstGeom prst="rect">
@@ -12502,7 +12564,7 @@
         </p:nvSpPr>
         <p:spPr>
           <a:xfrm>
-            <a:off x="533400" y="9474200"/>
+            <a:off x="533400" y="9398000"/>
             <a:ext cx="5791200" cy="6350"/>
           </a:xfrm>
           <a:prstGeom prst="rect">
@@ -12548,7 +12610,7 @@
         </p:nvSpPr>
         <p:spPr>
           <a:xfrm>
-            <a:off x="533400" y="9588500"/>
+            <a:off x="533400" y="9512300"/>
             <a:ext cx="571500" cy="254000"/>
           </a:xfrm>
           <a:prstGeom prst="rect">
@@ -12589,7 +12651,7 @@
         </p:nvSpPr>
         <p:spPr>
           <a:xfrm>
-            <a:off x="1206500" y="9537700"/>
+            <a:off x="1206500" y="9461500"/>
             <a:ext cx="4445000" cy="279400"/>
           </a:xfrm>
           <a:prstGeom prst="rect">
@@ -12630,7 +12692,7 @@
         </p:nvSpPr>
         <p:spPr>
           <a:xfrm>
-            <a:off x="1206500" y="9766300"/>
+            <a:off x="1206500" y="9690100"/>
             <a:ext cx="4953000" cy="215900"/>
           </a:xfrm>
           <a:prstGeom prst="rect">
@@ -12671,7 +12733,7 @@
         </p:nvSpPr>
         <p:spPr>
           <a:xfrm>
-            <a:off x="533400" y="10033000"/>
+            <a:off x="533400" y="9956800"/>
             <a:ext cx="5791200" cy="6350"/>
           </a:xfrm>
           <a:prstGeom prst="rect">
@@ -12717,7 +12779,7 @@
         </p:nvSpPr>
         <p:spPr>
           <a:xfrm>
-            <a:off x="533400" y="10147300"/>
+            <a:off x="533400" y="10071100"/>
             <a:ext cx="571500" cy="254000"/>
           </a:xfrm>
           <a:prstGeom prst="rect">
@@ -12758,7 +12820,7 @@
         </p:nvSpPr>
         <p:spPr>
           <a:xfrm>
-            <a:off x="1206500" y="10096500"/>
+            <a:off x="1206500" y="10020300"/>
             <a:ext cx="4445000" cy="279400"/>
           </a:xfrm>
           <a:prstGeom prst="rect">
@@ -12799,7 +12861,7 @@
         </p:nvSpPr>
         <p:spPr>
           <a:xfrm>
-            <a:off x="1206500" y="10325100"/>
+            <a:off x="1206500" y="10248900"/>
             <a:ext cx="4953000" cy="215900"/>
           </a:xfrm>
           <a:prstGeom prst="rect">
@@ -12840,7 +12902,7 @@
         </p:nvSpPr>
         <p:spPr>
           <a:xfrm>
-            <a:off x="533400" y="10591800"/>
+            <a:off x="533400" y="10515600"/>
             <a:ext cx="5791200" cy="6350"/>
           </a:xfrm>
           <a:prstGeom prst="rect">
@@ -12886,7 +12948,7 @@
         </p:nvSpPr>
         <p:spPr>
           <a:xfrm>
-            <a:off x="533400" y="10706100"/>
+            <a:off x="533400" y="10629900"/>
             <a:ext cx="571500" cy="254000"/>
           </a:xfrm>
           <a:prstGeom prst="rect">
@@ -12927,7 +12989,7 @@
         </p:nvSpPr>
         <p:spPr>
           <a:xfrm>
-            <a:off x="1206500" y="10655300"/>
+            <a:off x="1206500" y="10579100"/>
             <a:ext cx="4445000" cy="279400"/>
           </a:xfrm>
           <a:prstGeom prst="rect">
@@ -12968,7 +13030,7 @@
         </p:nvSpPr>
         <p:spPr>
           <a:xfrm>
-            <a:off x="1206500" y="10883900"/>
+            <a:off x="1206500" y="10807700"/>
             <a:ext cx="4953000" cy="215900"/>
           </a:xfrm>
           <a:prstGeom prst="rect">
@@ -13001,16 +13063,40 @@
           </a:p>
         </p:txBody>
       </p:sp>
-      <p:sp>
-        <p:nvSpPr>
-          <p:cNvPr id="30" name="TextBox 29"/>
+      <p:pic>
+        <p:nvPicPr>
+          <p:cNvPr id="30" name="GRANDRIMS logo" descr="logo_light.png"/>
+          <p:cNvPicPr>
+            <a:picLocks noChangeAspect="1"/>
+          </p:cNvPicPr>
+          <p:nvPr/>
+        </p:nvPicPr>
+        <p:blipFill>
+          <a:blip r:embed="rId3"/>
+          <a:stretch>
+            <a:fillRect/>
+          </a:stretch>
+        </p:blipFill>
+        <p:spPr>
+          <a:xfrm>
+            <a:off x="4965700" y="482600"/>
+            <a:ext cx="1358900" cy="439502"/>
+          </a:xfrm>
+          <a:prstGeom prst="rect">
+            <a:avLst/>
+          </a:prstGeom>
+        </p:spPr>
+      </p:pic>
+      <p:sp>
+        <p:nvSpPr>
+          <p:cNvPr id="31" name="TextBox 30"/>
           <p:cNvSpPr txBox="1"/>
           <p:nvPr/>
         </p:nvSpPr>
         <p:spPr>
           <a:xfrm>
             <a:off x="533400" y="11671300"/>
-            <a:ext cx="3175000" cy="190500"/>
+            <a:ext cx="3556000" cy="190500"/>
           </a:xfrm>
           <a:prstGeom prst="rect">
             <a:avLst/>
@@ -13037,14 +13123,14 @@
                 <a:ea typeface="Montserrat Medium"/>
                 <a:cs typeface="Montserrat Medium"/>
               </a:rPr>
-              <a:t>GRANDRIMS</a:t>
-            </a:r>
-          </a:p>
-        </p:txBody>
-      </p:sp>
-      <p:sp>
-        <p:nvSpPr>
-          <p:cNvPr id="31" name="Rectangle 30"/>
+              <a:t>КОММЕРЧЕСКОЕ ПРЕДЛОЖЕНИЕ</a:t>
+            </a:r>
+          </a:p>
+        </p:txBody>
+      </p:sp>
+      <p:sp>
+        <p:nvSpPr>
+          <p:cNvPr id="32" name="Rectangle 31"/>
           <p:cNvSpPr/>
           <p:nvPr/>
         </p:nvSpPr>
@@ -13088,7 +13174,7 @@
       </p:sp>
       <p:sp>
         <p:nvSpPr>
-          <p:cNvPr id="32" name="TextBox 31"/>
+          <p:cNvPr id="33" name="TextBox 32"/>
           <p:cNvSpPr txBox="1"/>
           <p:nvPr/>
         </p:nvSpPr>
@@ -13385,7 +13471,7 @@
         <p:spPr>
           <a:xfrm>
             <a:off x="533400" y="10325100"/>
-            <a:ext cx="3429000" cy="952500"/>
+            <a:ext cx="3175000" cy="952500"/>
           </a:xfrm>
           <a:prstGeom prst="rect">
             <a:avLst/>
@@ -13420,16 +13506,40 @@
           </a:p>
         </p:txBody>
       </p:sp>
-      <p:sp>
-        <p:nvSpPr>
-          <p:cNvPr id="8" name="TextBox 7"/>
+      <p:pic>
+        <p:nvPicPr>
+          <p:cNvPr id="8" name="GRANDRIMS logo" descr="logo_dark.png"/>
+          <p:cNvPicPr>
+            <a:picLocks noChangeAspect="1"/>
+          </p:cNvPicPr>
+          <p:nvPr/>
+        </p:nvPicPr>
+        <p:blipFill>
+          <a:blip r:embed="rId3"/>
+          <a:stretch>
+            <a:fillRect/>
+          </a:stretch>
+        </p:blipFill>
+        <p:spPr>
+          <a:xfrm>
+            <a:off x="4965700" y="482600"/>
+            <a:ext cx="1358900" cy="439502"/>
+          </a:xfrm>
+          <a:prstGeom prst="rect">
+            <a:avLst/>
+          </a:prstGeom>
+        </p:spPr>
+      </p:pic>
+      <p:sp>
+        <p:nvSpPr>
+          <p:cNvPr id="9" name="TextBox 8"/>
           <p:cNvSpPr txBox="1"/>
           <p:nvPr/>
         </p:nvSpPr>
         <p:spPr>
           <a:xfrm>
             <a:off x="533400" y="11671300"/>
-            <a:ext cx="3175000" cy="190500"/>
+            <a:ext cx="3556000" cy="190500"/>
           </a:xfrm>
           <a:prstGeom prst="rect">
             <a:avLst/>
@@ -13456,14 +13566,14 @@
                 <a:ea typeface="Montserrat Medium"/>
                 <a:cs typeface="Montserrat Medium"/>
               </a:rPr>
-              <a:t>GRANDRIMS</a:t>
-            </a:r>
-          </a:p>
-        </p:txBody>
-      </p:sp>
-      <p:sp>
-        <p:nvSpPr>
-          <p:cNvPr id="9" name="Rectangle 8"/>
+              <a:t>КОММЕРЧЕСКОЕ ПРЕДЛОЖЕНИЕ</a:t>
+            </a:r>
+          </a:p>
+        </p:txBody>
+      </p:sp>
+      <p:sp>
+        <p:nvSpPr>
+          <p:cNvPr id="10" name="Rectangle 9"/>
           <p:cNvSpPr/>
           <p:nvPr/>
         </p:nvSpPr>
@@ -13507,7 +13617,7 @@
       </p:sp>
       <p:sp>
         <p:nvSpPr>
-          <p:cNvPr id="10" name="TextBox 9"/>
+          <p:cNvPr id="11" name="TextBox 10"/>
           <p:cNvSpPr txBox="1"/>
           <p:nvPr/>
         </p:nvSpPr>
@@ -13814,16 +13924,40 @@
           </a:p>
         </p:txBody>
       </p:sp>
-      <p:sp>
-        <p:nvSpPr>
-          <p:cNvPr id="7" name="TextBox 6"/>
+      <p:pic>
+        <p:nvPicPr>
+          <p:cNvPr id="7" name="GRANDRIMS logo" descr="logo_dark.png"/>
+          <p:cNvPicPr>
+            <a:picLocks noChangeAspect="1"/>
+          </p:cNvPicPr>
+          <p:nvPr/>
+        </p:nvPicPr>
+        <p:blipFill>
+          <a:blip r:embed="rId3"/>
+          <a:stretch>
+            <a:fillRect/>
+          </a:stretch>
+        </p:blipFill>
+        <p:spPr>
+          <a:xfrm>
+            <a:off x="4965700" y="482600"/>
+            <a:ext cx="1358900" cy="439502"/>
+          </a:xfrm>
+          <a:prstGeom prst="rect">
+            <a:avLst/>
+          </a:prstGeom>
+        </p:spPr>
+      </p:pic>
+      <p:sp>
+        <p:nvSpPr>
+          <p:cNvPr id="8" name="TextBox 7"/>
           <p:cNvSpPr txBox="1"/>
           <p:nvPr/>
         </p:nvSpPr>
         <p:spPr>
           <a:xfrm>
             <a:off x="533400" y="11671300"/>
-            <a:ext cx="3175000" cy="190500"/>
+            <a:ext cx="3556000" cy="190500"/>
           </a:xfrm>
           <a:prstGeom prst="rect">
             <a:avLst/>
@@ -13850,14 +13984,14 @@
                 <a:ea typeface="Montserrat Medium"/>
                 <a:cs typeface="Montserrat Medium"/>
               </a:rPr>
-              <a:t>GRANDRIMS</a:t>
-            </a:r>
-          </a:p>
-        </p:txBody>
-      </p:sp>
-      <p:sp>
-        <p:nvSpPr>
-          <p:cNvPr id="8" name="Rectangle 7"/>
+              <a:t>КОММЕРЧЕСКОЕ ПРЕДЛОЖЕНИЕ</a:t>
+            </a:r>
+          </a:p>
+        </p:txBody>
+      </p:sp>
+      <p:sp>
+        <p:nvSpPr>
+          <p:cNvPr id="9" name="Rectangle 8"/>
           <p:cNvSpPr/>
           <p:nvPr/>
         </p:nvSpPr>
@@ -13901,7 +14035,7 @@
       </p:sp>
       <p:sp>
         <p:nvSpPr>
-          <p:cNvPr id="9" name="TextBox 8"/>
+          <p:cNvPr id="10" name="TextBox 9"/>
           <p:cNvSpPr txBox="1"/>
           <p:nvPr/>
         </p:nvSpPr>
@@ -14152,7 +14286,7 @@
         <p:spPr>
           <a:xfrm>
             <a:off x="533400" y="9842500"/>
-            <a:ext cx="3556000" cy="1079500"/>
+            <a:ext cx="3175000" cy="1079500"/>
           </a:xfrm>
           <a:prstGeom prst="rect">
             <a:avLst/>
@@ -14187,16 +14321,40 @@
           </a:p>
         </p:txBody>
       </p:sp>
-      <p:sp>
-        <p:nvSpPr>
-          <p:cNvPr id="7" name="TextBox 6"/>
+      <p:pic>
+        <p:nvPicPr>
+          <p:cNvPr id="7" name="GRANDRIMS logo" descr="logo_dark.png"/>
+          <p:cNvPicPr>
+            <a:picLocks noChangeAspect="1"/>
+          </p:cNvPicPr>
+          <p:nvPr/>
+        </p:nvPicPr>
+        <p:blipFill>
+          <a:blip r:embed="rId3"/>
+          <a:stretch>
+            <a:fillRect/>
+          </a:stretch>
+        </p:blipFill>
+        <p:spPr>
+          <a:xfrm>
+            <a:off x="4965700" y="482600"/>
+            <a:ext cx="1358900" cy="439502"/>
+          </a:xfrm>
+          <a:prstGeom prst="rect">
+            <a:avLst/>
+          </a:prstGeom>
+        </p:spPr>
+      </p:pic>
+      <p:sp>
+        <p:nvSpPr>
+          <p:cNvPr id="8" name="TextBox 7"/>
           <p:cNvSpPr txBox="1"/>
           <p:nvPr/>
         </p:nvSpPr>
         <p:spPr>
           <a:xfrm>
             <a:off x="533400" y="11671300"/>
-            <a:ext cx="3175000" cy="190500"/>
+            <a:ext cx="3556000" cy="190500"/>
           </a:xfrm>
           <a:prstGeom prst="rect">
             <a:avLst/>
@@ -14223,14 +14381,14 @@
                 <a:ea typeface="Montserrat Medium"/>
                 <a:cs typeface="Montserrat Medium"/>
               </a:rPr>
-              <a:t>GRANDRIMS</a:t>
-            </a:r>
-          </a:p>
-        </p:txBody>
-      </p:sp>
-      <p:sp>
-        <p:nvSpPr>
-          <p:cNvPr id="8" name="Rectangle 7"/>
+              <a:t>КОММЕРЧЕСКОЕ ПРЕДЛОЖЕНИЕ</a:t>
+            </a:r>
+          </a:p>
+        </p:txBody>
+      </p:sp>
+      <p:sp>
+        <p:nvSpPr>
+          <p:cNvPr id="9" name="Rectangle 8"/>
           <p:cNvSpPr/>
           <p:nvPr/>
         </p:nvSpPr>
@@ -14274,7 +14432,7 @@
       </p:sp>
       <p:sp>
         <p:nvSpPr>
-          <p:cNvPr id="9" name="TextBox 8"/>
+          <p:cNvPr id="10" name="TextBox 9"/>
           <p:cNvSpPr txBox="1"/>
           <p:nvPr/>
         </p:nvSpPr>
@@ -15067,16 +15225,40 @@
           </a:p>
         </p:txBody>
       </p:sp>
-      <p:sp>
-        <p:nvSpPr>
-          <p:cNvPr id="18" name="TextBox 17"/>
+      <p:pic>
+        <p:nvPicPr>
+          <p:cNvPr id="18" name="GRANDRIMS logo" descr="logo_dark.png"/>
+          <p:cNvPicPr>
+            <a:picLocks noChangeAspect="1"/>
+          </p:cNvPicPr>
+          <p:nvPr/>
+        </p:nvPicPr>
+        <p:blipFill>
+          <a:blip r:embed="rId4"/>
+          <a:stretch>
+            <a:fillRect/>
+          </a:stretch>
+        </p:blipFill>
+        <p:spPr>
+          <a:xfrm>
+            <a:off x="4965700" y="482600"/>
+            <a:ext cx="1358900" cy="439502"/>
+          </a:xfrm>
+          <a:prstGeom prst="rect">
+            <a:avLst/>
+          </a:prstGeom>
+        </p:spPr>
+      </p:pic>
+      <p:sp>
+        <p:nvSpPr>
+          <p:cNvPr id="19" name="TextBox 18"/>
           <p:cNvSpPr txBox="1"/>
           <p:nvPr/>
         </p:nvSpPr>
         <p:spPr>
           <a:xfrm>
             <a:off x="533400" y="11671300"/>
-            <a:ext cx="3175000" cy="190500"/>
+            <a:ext cx="3556000" cy="190500"/>
           </a:xfrm>
           <a:prstGeom prst="rect">
             <a:avLst/>
@@ -15103,14 +15285,14 @@
                 <a:ea typeface="Montserrat Medium"/>
                 <a:cs typeface="Montserrat Medium"/>
               </a:rPr>
-              <a:t>GRANDRIMS</a:t>
-            </a:r>
-          </a:p>
-        </p:txBody>
-      </p:sp>
-      <p:sp>
-        <p:nvSpPr>
-          <p:cNvPr id="19" name="Rectangle 18"/>
+              <a:t>КОММЕРЧЕСКОЕ ПРЕДЛОЖЕНИЕ</a:t>
+            </a:r>
+          </a:p>
+        </p:txBody>
+      </p:sp>
+      <p:sp>
+        <p:nvSpPr>
+          <p:cNvPr id="20" name="Rectangle 19"/>
           <p:cNvSpPr/>
           <p:nvPr/>
         </p:nvSpPr>
@@ -15154,7 +15336,7 @@
       </p:sp>
       <p:sp>
         <p:nvSpPr>
-          <p:cNvPr id="20" name="TextBox 19"/>
+          <p:cNvPr id="21" name="TextBox 20"/>
           <p:cNvSpPr txBox="1"/>
           <p:nvPr/>
         </p:nvSpPr>

</xml_diff>

<commit_message>
GRANDRIMS x Mercedes-Benz deck: G 63 kit text and price, new wheel prices, inch marks, new inset photos
Co-Authored-By: Claude Sonnet 5.5 <noreply@anthropic.com>
Claude-Session: https://claude.ai/code/session_01Gh1izjdNn5w7VE18yf9oT6
</commit_message>
<xml_diff>
--- a/grandrims-mb/GRANDRIMS_Mercedes-Benz_KP.pptx
+++ b/grandrims-mb/GRANDRIMS_Mercedes-Benz_KP.pptx
@@ -584,7 +584,7 @@
           <a:lstStyle/>
           <a:p>
             <a:r>
-              <a:t>ТРЕБУЕТСЯ: внести цену вместо «…» в текстовом поле «Price text». Цена не придумана.</a:t>
+              <a:t>Состав комплекта и цена — из сообщения заказчика: передний суппорт Brembo 6pot + карбон-керамические диски 420 мм, задний суппорт OEM 1pot + диски 400 мм; W463 / W465; 1 150 000 ₽ (стрелка вверх в исходнике передана как «от»).</a:t>
             </a:r>
           </a:p>
         </p:txBody>
@@ -724,7 +724,7 @@
           <a:lstStyle/>
           <a:p>
             <a:r>
-              <a:t>Прайс-лист перенесён без изменений из исходного КП (значения «от», моноблоки и 2-составные, 18–24″). Единица цены (за диск / за комплект) в исходнике не указана — при необходимости уточнить и добавить.</a:t>
+              <a:t>Цены на диски (моноблоки и 2-составные, 18″–24″) — из актуального сообщения заказчика; заменили прежний прайс «от» из старого КП. Единица цены (за диск / за комплект) не указана.</a:t>
             </a:r>
           </a:p>
         </p:txBody>
@@ -1004,7 +1004,7 @@
           <a:lstStyle/>
           <a:p>
             <a:r>
-              <a:t>Технологии и преимущества. Все факты — из исходного КП: 6061-T6, 18–24″, 3D, от 15 рабочих дней, пожизненная гарантия на целостность конструкции, сервис, готовые комплекты.</a:t>
+              <a:t>Технологии и преимущества. Все факты — из исходного КП: 6061-T6, 18″–24″, 3D, от 15 рабочих дней, пожизненная гарантия на целостность конструкции, сервис, готовые комплекты.</a:t>
             </a:r>
           </a:p>
         </p:txBody>
@@ -4823,7 +4823,7 @@
         <p:spPr>
           <a:xfrm>
             <a:off x="533400" y="1117600"/>
-            <a:ext cx="5842000" cy="1905000"/>
+            <a:ext cx="5842000" cy="1524000"/>
           </a:xfrm>
           <a:prstGeom prst="rect">
             <a:avLst/>
@@ -4916,8 +4916,8 @@
         </p:blipFill>
         <p:spPr>
           <a:xfrm>
-            <a:off x="0" y="2794000"/>
-            <a:ext cx="6858000" cy="4572000"/>
+            <a:off x="0" y="2730500"/>
+            <a:ext cx="6858000" cy="3365500"/>
           </a:xfrm>
           <a:prstGeom prst="rect">
             <a:avLst/>
@@ -4932,7 +4932,7 @@
         </p:nvSpPr>
         <p:spPr>
           <a:xfrm>
-            <a:off x="0" y="2794000"/>
+            <a:off x="0" y="2730500"/>
             <a:ext cx="6858000" cy="6350"/>
           </a:xfrm>
           <a:prstGeom prst="rect">
@@ -4978,7 +4978,7 @@
         </p:nvSpPr>
         <p:spPr>
           <a:xfrm>
-            <a:off x="0" y="7366000"/>
+            <a:off x="0" y="6096000"/>
             <a:ext cx="6858000" cy="6350"/>
           </a:xfrm>
           <a:prstGeom prst="rect">
@@ -5018,14 +5018,14 @@
       </p:sp>
       <p:sp>
         <p:nvSpPr>
-          <p:cNvPr id="9" name="Price text"/>
+          <p:cNvPr id="9" name="TextBox 8"/>
           <p:cNvSpPr txBox="1"/>
           <p:nvPr/>
         </p:nvSpPr>
         <p:spPr>
           <a:xfrm>
-            <a:off x="533400" y="7594600"/>
-            <a:ext cx="5842000" cy="2540000"/>
+            <a:off x="533400" y="6299200"/>
+            <a:ext cx="4445000" cy="190500"/>
           </a:xfrm>
           <a:prstGeom prst="rect">
             <a:avLst/>
@@ -5039,48 +5039,244 @@
           <a:lstStyle/>
           <a:p>
             <a:pPr algn="l">
+              <a:spcBef>
+                <a:spcPts val="0"/>
+              </a:spcBef>
+            </a:pPr>
+            <a:r>
+              <a:rPr sz="1000" lang="ru-RU" spc="200">
+                <a:solidFill>
+                  <a:srgbClr val="8C939A"/>
+                </a:solidFill>
+                <a:latin typeface="Montserrat Medium"/>
+                <a:ea typeface="Montserrat Medium"/>
+                <a:cs typeface="Montserrat Medium"/>
+              </a:rPr>
+              <a:t>В КОМПЛЕКТЕ</a:t>
+            </a:r>
+          </a:p>
+        </p:txBody>
+      </p:sp>
+      <p:sp>
+        <p:nvSpPr>
+          <p:cNvPr id="10" name="TextBox 9"/>
+          <p:cNvSpPr txBox="1"/>
+          <p:nvPr/>
+        </p:nvSpPr>
+        <p:spPr>
+          <a:xfrm>
+            <a:off x="533400" y="6604000"/>
+            <a:ext cx="381000" cy="190500"/>
+          </a:xfrm>
+          <a:prstGeom prst="rect">
+            <a:avLst/>
+          </a:prstGeom>
+          <a:noFill/>
+        </p:spPr>
+        <p:txBody>
+          <a:bodyPr wrap="square" lIns="0" rIns="0" tIns="0" bIns="0" anchor="t">
+            <a:noAutofit/>
+          </a:bodyPr>
+          <a:lstStyle/>
+          <a:p>
+            <a:pPr algn="l">
+              <a:spcBef>
+                <a:spcPts val="0"/>
+              </a:spcBef>
+            </a:pPr>
+            <a:r>
+              <a:rPr sz="1000" lang="ru-RU" spc="150">
+                <a:solidFill>
+                  <a:srgbClr val="8C939A"/>
+                </a:solidFill>
+                <a:latin typeface="Montserrat Medium"/>
+                <a:ea typeface="Montserrat Medium"/>
+                <a:cs typeface="Montserrat Medium"/>
+              </a:rPr>
+              <a:t>01</a:t>
+            </a:r>
+          </a:p>
+        </p:txBody>
+      </p:sp>
+      <p:sp>
+        <p:nvSpPr>
+          <p:cNvPr id="11" name="TextBox 10"/>
+          <p:cNvSpPr txBox="1"/>
+          <p:nvPr/>
+        </p:nvSpPr>
+        <p:spPr>
+          <a:xfrm>
+            <a:off x="1016000" y="6565900"/>
+            <a:ext cx="5308600" cy="571500"/>
+          </a:xfrm>
+          <a:prstGeom prst="rect">
+            <a:avLst/>
+          </a:prstGeom>
+          <a:noFill/>
+        </p:spPr>
+        <p:txBody>
+          <a:bodyPr wrap="square" lIns="0" rIns="0" tIns="0" bIns="0" anchor="t">
+            <a:noAutofit/>
+          </a:bodyPr>
+          <a:lstStyle/>
+          <a:p>
+            <a:pPr algn="l">
               <a:lnSpc>
-                <a:spcPct val="125000"/>
+                <a:spcPts val="2000"/>
               </a:lnSpc>
               <a:spcBef>
                 <a:spcPts val="0"/>
               </a:spcBef>
             </a:pPr>
             <a:r>
-              <a:rPr sz="1700" lang="ru-RU">
-                <a:solidFill>
-                  <a:srgbClr val="C4C9CE"/>
+              <a:rPr sz="1400" lang="ru-RU">
+                <a:solidFill>
+                  <a:srgbClr val="FFFFFF"/>
                 </a:solidFill>
                 <a:latin typeface="Montserrat Light"/>
                 <a:ea typeface="Montserrat Light"/>
                 <a:cs typeface="Montserrat Light"/>
               </a:rPr>
-              <a:t>Стоимость представленного на фотографии комплекта карбон-керамической тормозной системы для Mercedes-Benz G 63 составляет</a:t>
-            </a:r>
-            <a:br/>
-            <a:r>
-              <a:rPr sz="7500" lang="ru-RU">
+              <a:t>Передний суппорт Brembo 6pot + карбон-керамические тормозные диски 420 мм</a:t>
+            </a:r>
+          </a:p>
+        </p:txBody>
+      </p:sp>
+      <p:sp>
+        <p:nvSpPr>
+          <p:cNvPr id="12" name="TextBox 11"/>
+          <p:cNvSpPr txBox="1"/>
+          <p:nvPr/>
+        </p:nvSpPr>
+        <p:spPr>
+          <a:xfrm>
+            <a:off x="533400" y="7188200"/>
+            <a:ext cx="381000" cy="190500"/>
+          </a:xfrm>
+          <a:prstGeom prst="rect">
+            <a:avLst/>
+          </a:prstGeom>
+          <a:noFill/>
+        </p:spPr>
+        <p:txBody>
+          <a:bodyPr wrap="square" lIns="0" rIns="0" tIns="0" bIns="0" anchor="t">
+            <a:noAutofit/>
+          </a:bodyPr>
+          <a:lstStyle/>
+          <a:p>
+            <a:pPr algn="l">
+              <a:spcBef>
+                <a:spcPts val="0"/>
+              </a:spcBef>
+            </a:pPr>
+            <a:r>
+              <a:rPr sz="1000" lang="ru-RU" spc="150">
+                <a:solidFill>
+                  <a:srgbClr val="8C939A"/>
+                </a:solidFill>
+                <a:latin typeface="Montserrat Medium"/>
+                <a:ea typeface="Montserrat Medium"/>
+                <a:cs typeface="Montserrat Medium"/>
+              </a:rPr>
+              <a:t>02</a:t>
+            </a:r>
+          </a:p>
+        </p:txBody>
+      </p:sp>
+      <p:sp>
+        <p:nvSpPr>
+          <p:cNvPr id="13" name="TextBox 12"/>
+          <p:cNvSpPr txBox="1"/>
+          <p:nvPr/>
+        </p:nvSpPr>
+        <p:spPr>
+          <a:xfrm>
+            <a:off x="1016000" y="7150100"/>
+            <a:ext cx="5308600" cy="571500"/>
+          </a:xfrm>
+          <a:prstGeom prst="rect">
+            <a:avLst/>
+          </a:prstGeom>
+          <a:noFill/>
+        </p:spPr>
+        <p:txBody>
+          <a:bodyPr wrap="square" lIns="0" rIns="0" tIns="0" bIns="0" anchor="t">
+            <a:noAutofit/>
+          </a:bodyPr>
+          <a:lstStyle/>
+          <a:p>
+            <a:pPr algn="l">
+              <a:lnSpc>
+                <a:spcPts val="2000"/>
+              </a:lnSpc>
+              <a:spcBef>
+                <a:spcPts val="0"/>
+              </a:spcBef>
+            </a:pPr>
+            <a:r>
+              <a:rPr sz="1400" lang="ru-RU">
                 <a:solidFill>
                   <a:srgbClr val="FFFFFF"/>
                 </a:solidFill>
-                <a:latin typeface="Montserrat SemiBold"/>
-                <a:ea typeface="Montserrat SemiBold"/>
-                <a:cs typeface="Montserrat SemiBold"/>
-              </a:rPr>
-              <a:t>… ₽.</a:t>
-            </a:r>
-          </a:p>
-        </p:txBody>
-      </p:sp>
-      <p:sp>
-        <p:nvSpPr>
-          <p:cNvPr id="10" name="Rectangle 9"/>
+                <a:latin typeface="Montserrat Light"/>
+                <a:ea typeface="Montserrat Light"/>
+                <a:cs typeface="Montserrat Light"/>
+              </a:rPr>
+              <a:t>Задний суппорт OEM 1pot + карбон-керамические тормозные диски 400 мм</a:t>
+            </a:r>
+          </a:p>
+        </p:txBody>
+      </p:sp>
+      <p:sp>
+        <p:nvSpPr>
+          <p:cNvPr id="14" name="TextBox 13"/>
+          <p:cNvSpPr txBox="1"/>
+          <p:nvPr/>
+        </p:nvSpPr>
+        <p:spPr>
+          <a:xfrm>
+            <a:off x="533400" y="7848600"/>
+            <a:ext cx="5791200" cy="279400"/>
+          </a:xfrm>
+          <a:prstGeom prst="rect">
+            <a:avLst/>
+          </a:prstGeom>
+          <a:noFill/>
+        </p:spPr>
+        <p:txBody>
+          <a:bodyPr wrap="square" lIns="0" rIns="0" tIns="0" bIns="0" anchor="t">
+            <a:noAutofit/>
+          </a:bodyPr>
+          <a:lstStyle/>
+          <a:p>
+            <a:pPr algn="l">
+              <a:spcBef>
+                <a:spcPts val="0"/>
+              </a:spcBef>
+            </a:pPr>
+            <a:r>
+              <a:rPr sz="1400" lang="ru-RU">
+                <a:solidFill>
+                  <a:srgbClr val="C4C9CE"/>
+                </a:solidFill>
+                <a:latin typeface="Montserrat Medium"/>
+                <a:ea typeface="Montserrat Medium"/>
+                <a:cs typeface="Montserrat Medium"/>
+              </a:rPr>
+              <a:t>Подходит для Mercedes-Benz W463 / W465</a:t>
+            </a:r>
+          </a:p>
+        </p:txBody>
+      </p:sp>
+      <p:sp>
+        <p:nvSpPr>
+          <p:cNvPr id="15" name="Rectangle 14"/>
           <p:cNvSpPr/>
           <p:nvPr/>
         </p:nvSpPr>
         <p:spPr>
           <a:xfrm>
-            <a:off x="533400" y="10223500"/>
+            <a:off x="533400" y="8280400"/>
             <a:ext cx="762000" cy="6350"/>
           </a:xfrm>
           <a:prstGeom prst="rect">
@@ -5120,14 +5316,14 @@
       </p:sp>
       <p:sp>
         <p:nvSpPr>
-          <p:cNvPr id="11" name="Note"/>
+          <p:cNvPr id="16" name="Price text"/>
           <p:cNvSpPr txBox="1"/>
           <p:nvPr/>
         </p:nvSpPr>
         <p:spPr>
           <a:xfrm>
-            <a:off x="533400" y="10375900"/>
-            <a:ext cx="5791200" cy="952500"/>
+            <a:off x="533400" y="8420100"/>
+            <a:ext cx="5842000" cy="2095500"/>
           </a:xfrm>
           <a:prstGeom prst="rect">
             <a:avLst/>
@@ -5142,21 +5338,77 @@
           <a:p>
             <a:pPr algn="l">
               <a:lnSpc>
-                <a:spcPts val="1800"/>
+                <a:spcPct val="125000"/>
               </a:lnSpc>
               <a:spcBef>
                 <a:spcPts val="0"/>
               </a:spcBef>
             </a:pPr>
             <a:r>
-              <a:rPr sz="1250" lang="ru-RU">
-                <a:solidFill>
-                  <a:srgbClr val="8C939A"/>
+              <a:rPr sz="1600" lang="ru-RU">
+                <a:solidFill>
+                  <a:srgbClr val="C4C9CE"/>
                 </a:solidFill>
                 <a:latin typeface="Montserrat Light"/>
                 <a:ea typeface="Montserrat Light"/>
                 <a:cs typeface="Montserrat Light"/>
               </a:rPr>
+              <a:t>Стоимость представленного на фотографии комплекта карбон-керамической тормозной системы для Mercedes-Benz G 63 составляет</a:t>
+            </a:r>
+            <a:br/>
+            <a:r>
+              <a:rPr sz="4600" lang="ru-RU">
+                <a:solidFill>
+                  <a:srgbClr val="FFFFFF"/>
+                </a:solidFill>
+                <a:latin typeface="Montserrat SemiBold"/>
+                <a:ea typeface="Montserrat SemiBold"/>
+                <a:cs typeface="Montserrat SemiBold"/>
+              </a:rPr>
+              <a:t>от 1 150 000 ₽.</a:t>
+            </a:r>
+          </a:p>
+        </p:txBody>
+      </p:sp>
+      <p:sp>
+        <p:nvSpPr>
+          <p:cNvPr id="17" name="Note"/>
+          <p:cNvSpPr txBox="1"/>
+          <p:nvPr/>
+        </p:nvSpPr>
+        <p:spPr>
+          <a:xfrm>
+            <a:off x="533400" y="10591800"/>
+            <a:ext cx="5791200" cy="698500"/>
+          </a:xfrm>
+          <a:prstGeom prst="rect">
+            <a:avLst/>
+          </a:prstGeom>
+          <a:noFill/>
+        </p:spPr>
+        <p:txBody>
+          <a:bodyPr wrap="square" lIns="0" rIns="0" tIns="0" bIns="0" anchor="t">
+            <a:noAutofit/>
+          </a:bodyPr>
+          <a:lstStyle/>
+          <a:p>
+            <a:pPr algn="l">
+              <a:lnSpc>
+                <a:spcPts val="1700"/>
+              </a:lnSpc>
+              <a:spcBef>
+                <a:spcPts val="0"/>
+              </a:spcBef>
+            </a:pPr>
+            <a:r>
+              <a:rPr sz="1200" lang="ru-RU">
+                <a:solidFill>
+                  <a:srgbClr val="8C939A"/>
+                </a:solidFill>
+                <a:latin typeface="Montserrat Light"/>
+                <a:ea typeface="Montserrat Light"/>
+                <a:cs typeface="Montserrat Light"/>
+              </a:rPr>
               <a:t>Стоимость тормозной системы для конкретной модели автомобиля рассчитывается индивидуально с учётом конфигурации и необходимых компонентов.</a:t>
             </a:r>
           </a:p>
@@ -5164,7 +5416,7 @@
       </p:sp>
       <p:pic>
         <p:nvPicPr>
-          <p:cNvPr id="12" name="GRANDRIMS logo" descr="logo_dark.png"/>
+          <p:cNvPr id="18" name="GRANDRIMS logo" descr="logo_dark.png"/>
           <p:cNvPicPr>
             <a:picLocks noChangeAspect="1"/>
           </p:cNvPicPr>
@@ -5188,7 +5440,7 @@
       </p:pic>
       <p:sp>
         <p:nvSpPr>
-          <p:cNvPr id="13" name="TextBox 12"/>
+          <p:cNvPr id="19" name="TextBox 18"/>
           <p:cNvSpPr txBox="1"/>
           <p:nvPr/>
         </p:nvSpPr>
@@ -5229,7 +5481,7 @@
       </p:sp>
       <p:sp>
         <p:nvSpPr>
-          <p:cNvPr id="14" name="Rectangle 13"/>
+          <p:cNvPr id="20" name="Rectangle 19"/>
           <p:cNvSpPr/>
           <p:nvPr/>
         </p:nvSpPr>
@@ -5273,7 +5525,7 @@
       </p:sp>
       <p:sp>
         <p:nvSpPr>
-          <p:cNvPr id="15" name="TextBox 14"/>
+          <p:cNvPr id="21" name="TextBox 20"/>
           <p:cNvSpPr txBox="1"/>
           <p:nvPr/>
         </p:nvSpPr>
@@ -7773,7 +8025,7 @@
                 <a:ea typeface="Montserrat Light"/>
                 <a:cs typeface="Montserrat Light"/>
               </a:rPr>
-              <a:t>от 190 500 ₽</a:t>
+              <a:t>179 000 ₽</a:t>
             </a:r>
           </a:p>
         </p:txBody>
@@ -7814,7 +8066,7 @@
                 <a:ea typeface="Montserrat Light"/>
                 <a:cs typeface="Montserrat Light"/>
               </a:rPr>
-              <a:t>от 320 000 ₽</a:t>
+              <a:t>279 000 ₽</a:t>
             </a:r>
           </a:p>
         </p:txBody>
@@ -7942,7 +8194,7 @@
                 <a:ea typeface="Montserrat Light"/>
                 <a:cs typeface="Montserrat Light"/>
               </a:rPr>
-              <a:t>от 201 500 ₽</a:t>
+              <a:t>190 000 ₽</a:t>
             </a:r>
           </a:p>
         </p:txBody>
@@ -7983,7 +8235,7 @@
                 <a:ea typeface="Montserrat Light"/>
                 <a:cs typeface="Montserrat Light"/>
               </a:rPr>
-              <a:t>от 341 500 ₽</a:t>
+              <a:t>290 000 ₽</a:t>
             </a:r>
           </a:p>
         </p:txBody>
@@ -8111,7 +8363,7 @@
                 <a:ea typeface="Montserrat Light"/>
                 <a:cs typeface="Montserrat Light"/>
               </a:rPr>
-              <a:t>от 213 000 ₽</a:t>
+              <a:t>205 000 ₽</a:t>
             </a:r>
           </a:p>
         </p:txBody>
@@ -8152,7 +8404,7 @@
                 <a:ea typeface="Montserrat Light"/>
                 <a:cs typeface="Montserrat Light"/>
               </a:rPr>
-              <a:t>от 364 000 ₽</a:t>
+              <a:t>305 000 ₽</a:t>
             </a:r>
           </a:p>
         </p:txBody>
@@ -8280,7 +8532,7 @@
                 <a:ea typeface="Montserrat Light"/>
                 <a:cs typeface="Montserrat Light"/>
               </a:rPr>
-              <a:t>от 235 000 ₽</a:t>
+              <a:t>218 000 ₽</a:t>
             </a:r>
           </a:p>
         </p:txBody>
@@ -8321,7 +8573,7 @@
                 <a:ea typeface="Montserrat Light"/>
                 <a:cs typeface="Montserrat Light"/>
               </a:rPr>
-              <a:t>от 397 500 ₽</a:t>
+              <a:t>318 000 ₽</a:t>
             </a:r>
           </a:p>
         </p:txBody>
@@ -8449,7 +8701,7 @@
                 <a:ea typeface="Montserrat Light"/>
                 <a:cs typeface="Montserrat Light"/>
               </a:rPr>
-              <a:t>от 257 500 ₽</a:t>
+              <a:t>230 000 ₽</a:t>
             </a:r>
           </a:p>
         </p:txBody>
@@ -8490,7 +8742,7 @@
                 <a:ea typeface="Montserrat Light"/>
                 <a:cs typeface="Montserrat Light"/>
               </a:rPr>
-              <a:t>от 442 500 ₽</a:t>
+              <a:t>330 000 ₽</a:t>
             </a:r>
           </a:p>
         </p:txBody>
@@ -8618,7 +8870,7 @@
                 <a:ea typeface="Montserrat Light"/>
                 <a:cs typeface="Montserrat Light"/>
               </a:rPr>
-              <a:t>от 280 000 ₽</a:t>
+              <a:t>245 000 ₽</a:t>
             </a:r>
           </a:p>
         </p:txBody>
@@ -8659,7 +8911,7 @@
                 <a:ea typeface="Montserrat Light"/>
                 <a:cs typeface="Montserrat Light"/>
               </a:rPr>
-              <a:t>от 504 000 ₽</a:t>
+              <a:t>345 000 ₽</a:t>
             </a:r>
           </a:p>
         </p:txBody>
@@ -8787,7 +9039,7 @@
                 <a:ea typeface="Montserrat Light"/>
                 <a:cs typeface="Montserrat Light"/>
               </a:rPr>
-              <a:t>от 313 000 ₽</a:t>
+              <a:t>270 000 ₽</a:t>
             </a:r>
           </a:p>
         </p:txBody>
@@ -8828,7 +9080,7 @@
                 <a:ea typeface="Montserrat Light"/>
                 <a:cs typeface="Montserrat Light"/>
               </a:rPr>
-              <a:t>от 543 000 ₽</a:t>
+              <a:t>370 000 ₽</a:t>
             </a:r>
           </a:p>
         </p:txBody>
@@ -10301,8 +10553,8 @@
         </p:nvSpPr>
         <p:spPr>
           <a:xfrm>
-            <a:off x="533400" y="4445000"/>
-            <a:ext cx="3556000" cy="1397000"/>
+            <a:off x="533400" y="4521200"/>
+            <a:ext cx="3937000" cy="1270000"/>
           </a:xfrm>
           <a:prstGeom prst="rect">
             <a:avLst/>
@@ -10317,14 +10569,14 @@
           <a:p>
             <a:pPr algn="l">
               <a:lnSpc>
-                <a:spcPts val="9500"/>
+                <a:spcPts val="8000"/>
               </a:lnSpc>
               <a:spcBef>
                 <a:spcPts val="0"/>
               </a:spcBef>
             </a:pPr>
             <a:r>
-              <a:rPr sz="8400" lang="ru-RU">
+              <a:rPr sz="7000" lang="ru-RU">
                 <a:solidFill>
                   <a:srgbClr val="FFFFFF"/>
                 </a:solidFill>
@@ -10332,7 +10584,7 @@
                 <a:ea typeface="Montserrat Light"/>
                 <a:cs typeface="Montserrat Light"/>
               </a:rPr>
-              <a:t>18–24″</a:t>
+              <a:t>18″–24″</a:t>
             </a:r>
           </a:p>
         </p:txBody>
@@ -10345,8 +10597,8 @@
         </p:nvSpPr>
         <p:spPr>
           <a:xfrm>
-            <a:off x="4127500" y="4686300"/>
-            <a:ext cx="2197100" cy="254000"/>
+            <a:off x="4521200" y="4775200"/>
+            <a:ext cx="1803400" cy="381000"/>
           </a:xfrm>
           <a:prstGeom prst="rect">
             <a:avLst/>
@@ -10386,8 +10638,8 @@
         </p:nvSpPr>
         <p:spPr>
           <a:xfrm>
-            <a:off x="4127500" y="5016500"/>
-            <a:ext cx="2197100" cy="952500"/>
+            <a:off x="533400" y="5613400"/>
+            <a:ext cx="5791200" cy="635000"/>
           </a:xfrm>
           <a:prstGeom prst="rect">
             <a:avLst/>
@@ -10402,14 +10654,14 @@
           <a:p>
             <a:pPr algn="l">
               <a:lnSpc>
-                <a:spcPts val="1950"/>
+                <a:spcPts val="2000"/>
               </a:lnSpc>
               <a:spcBef>
                 <a:spcPts val="0"/>
               </a:spcBef>
             </a:pPr>
             <a:r>
-              <a:rPr sz="1350" lang="ru-RU">
+              <a:rPr sz="1400" lang="ru-RU">
                 <a:solidFill>
                   <a:srgbClr val="C4C9CE"/>
                 </a:solidFill>
@@ -10994,7 +11246,7 @@
                 <a:ea typeface="Montserrat Light"/>
                 <a:cs typeface="Montserrat Light"/>
               </a:rPr>
-              <a:t>18–24″</a:t>
+              <a:t>18″–24″</a:t>
             </a:r>
           </a:p>
         </p:txBody>

</xml_diff>

<commit_message>
GRANDRIMS x Mercedes-Benz deck: Brembo on slide 9, drop 'от' on slide 10, 'Моноблоки' on slide 12
Co-Authored-By: Claude Sonnet 5.5 <noreply@anthropic.com>
Claude-Session: https://claude.ai/code/session_01Gh1izjdNn5w7VE18yf9oT6
</commit_message>
<xml_diff>
--- a/grandrims-mb/GRANDRIMS_Mercedes-Benz_KP.pptx
+++ b/grandrims-mb/GRANDRIMS_Mercedes-Benz_KP.pptx
@@ -584,7 +584,7 @@
           <a:lstStyle/>
           <a:p>
             <a:r>
-              <a:t>Состав комплекта и цена — из сообщения заказчика: передний суппорт Brembo 6pot + карбон-керамические диски 420 мм, задний суппорт OEM 1pot + диски 400 мм; W463 / W465; 1 150 000 ₽ (стрелка вверх в исходнике передана как «от»).</a:t>
+              <a:t>Состав комплекта и цена — из сообщения заказчика: передний суппорт Brembo 6pot + карбон-керамические диски 420 мм, задний суппорт OEM 1pot + диски 400 мм; W463 / W465; 1 150 000 ₽ (слово «от» убрано по просьбе заказчика).</a:t>
             </a:r>
           </a:p>
         </p:txBody>
@@ -5357,7 +5357,7 @@
             </a:r>
             <a:br/>
             <a:r>
-              <a:rPr sz="4600" lang="ru-RU">
+              <a:rPr sz="4800" lang="ru-RU">
                 <a:solidFill>
                   <a:srgbClr val="FFFFFF"/>
                 </a:solidFill>
@@ -5365,7 +5365,7 @@
                 <a:ea typeface="Montserrat SemiBold"/>
                 <a:cs typeface="Montserrat SemiBold"/>
               </a:rPr>
-              <a:t>от 1 150 000 ₽.</a:t>
+              <a:t>1 150 000 ₽.</a:t>
             </a:r>
           </a:p>
         </p:txBody>
@@ -7856,7 +7856,7 @@
                 <a:ea typeface="Montserrat Medium"/>
                 <a:cs typeface="Montserrat Medium"/>
               </a:rPr>
-              <a:t>МОНОБЛОК</a:t>
+              <a:t>МОНОБЛОКИ</a:t>
             </a:r>
           </a:p>
         </p:txBody>
@@ -15210,7 +15210,7 @@
                 <a:ea typeface="Montserrat Light"/>
                 <a:cs typeface="Montserrat Light"/>
               </a:rPr>
-              <a:t>AMG</a:t>
+              <a:t>Brembo</a:t>
             </a:r>
           </a:p>
         </p:txBody>

</xml_diff>